<commit_message>
new logo update and name change
</commit_message>
<xml_diff>
--- a/AharSetu_Board_Presentation.pptx
+++ b/AharSetu_Board_Presentation.pptx
@@ -5,22 +5,22 @@
     <p:sldMasterId id="2147483648" r:id="rId1"/>
   </p:sldMasterIdLst>
   <p:sldIdLst>
-    <p:sldId id="256" r:id="rId7"/>
-    <p:sldId id="257" r:id="rId8"/>
-    <p:sldId id="258" r:id="rId9"/>
-    <p:sldId id="259" r:id="rId10"/>
-    <p:sldId id="260" r:id="rId11"/>
-    <p:sldId id="261" r:id="rId12"/>
-    <p:sldId id="262" r:id="rId13"/>
-    <p:sldId id="263" r:id="rId14"/>
-    <p:sldId id="264" r:id="rId15"/>
-    <p:sldId id="265" r:id="rId16"/>
-    <p:sldId id="266" r:id="rId17"/>
-    <p:sldId id="267" r:id="rId18"/>
-    <p:sldId id="268" r:id="rId19"/>
-    <p:sldId id="269" r:id="rId20"/>
+    <p:sldId id="256" r:id="rId2"/>
+    <p:sldId id="257" r:id="rId3"/>
+    <p:sldId id="258" r:id="rId4"/>
+    <p:sldId id="259" r:id="rId5"/>
+    <p:sldId id="260" r:id="rId6"/>
+    <p:sldId id="261" r:id="rId7"/>
+    <p:sldId id="262" r:id="rId8"/>
+    <p:sldId id="263" r:id="rId9"/>
+    <p:sldId id="264" r:id="rId10"/>
+    <p:sldId id="265" r:id="rId11"/>
+    <p:sldId id="266" r:id="rId12"/>
+    <p:sldId id="267" r:id="rId13"/>
+    <p:sldId id="268" r:id="rId14"/>
+    <p:sldId id="269" r:id="rId15"/>
   </p:sldIdLst>
-  <p:sldSz cx="12191695" cy="6858000" type="screen4x3"/>
+  <p:sldSz cx="12192000" cy="6858000"/>
   <p:notesSz cx="6858000" cy="9144000"/>
   <p:defaultTextStyle>
     <a:defPPr>
@@ -117,6 +117,22 @@
       </a:defRPr>
     </a:lvl9pPr>
   </p:defaultTextStyle>
+  <p:extLst>
+    <p:ext uri="{EFAFB233-063F-42B5-8137-9DF3F51BA10A}">
+      <p15:sldGuideLst xmlns:p15="http://schemas.microsoft.com/office/powerpoint/2012/main">
+        <p15:guide id="1" orient="horz" pos="2160">
+          <p15:clr>
+            <a:srgbClr val="A4A3A4"/>
+          </p15:clr>
+        </p15:guide>
+        <p15:guide id="2" pos="2880">
+          <p15:clr>
+            <a:srgbClr val="A4A3A4"/>
+          </p15:clr>
+        </p15:guide>
+      </p15:sldGuideLst>
+    </p:ext>
+  </p:extLst>
 </p:presentation>
 </file>
 
@@ -158,10 +174,9 @@
           <a:lstStyle/>
           <a:p>
             <a:r>
-              <a:rPr lang="en-US" smtClean="0"/>
+              <a:rPr lang="en-US"/>
               <a:t>Click to edit Master title style</a:t>
             </a:r>
-            <a:endParaRPr lang="en-US"/>
           </a:p>
         </p:txBody>
       </p:sp>
@@ -277,10 +292,9 @@
           </a:lstStyle>
           <a:p>
             <a:r>
-              <a:rPr lang="en-US" smtClean="0"/>
+              <a:rPr lang="en-US"/>
               <a:t>Click to edit Master subtitle style</a:t>
             </a:r>
-            <a:endParaRPr lang="en-US"/>
           </a:p>
         </p:txBody>
       </p:sp>
@@ -301,7 +315,7 @@
           <a:p>
             <a:fld id="{5BCAD085-E8A6-8845-BD4E-CB4CCA059FC4}" type="datetimeFigureOut">
               <a:rPr lang="en-US" smtClean="0"/>
-              <a:t>1/27/13</a:t>
+              <a:t>8/19/26</a:t>
             </a:fld>
             <a:endParaRPr lang="en-US"/>
           </a:p>
@@ -395,10 +409,9 @@
           <a:lstStyle/>
           <a:p>
             <a:r>
-              <a:rPr lang="en-US" smtClean="0"/>
+              <a:rPr lang="en-US"/>
               <a:t>Click to edit Master title style</a:t>
             </a:r>
-            <a:endParaRPr lang="en-US"/>
           </a:p>
         </p:txBody>
       </p:sp>
@@ -419,38 +432,37 @@
           <a:p>
             <a:pPr lvl="0"/>
             <a:r>
-              <a:rPr lang="en-US" smtClean="0"/>
+              <a:rPr lang="en-US"/>
               <a:t>Click to edit Master text styles</a:t>
             </a:r>
           </a:p>
           <a:p>
             <a:pPr lvl="1"/>
             <a:r>
-              <a:rPr lang="en-US" smtClean="0"/>
+              <a:rPr lang="en-US"/>
               <a:t>Second level</a:t>
             </a:r>
           </a:p>
           <a:p>
             <a:pPr lvl="2"/>
             <a:r>
-              <a:rPr lang="en-US" smtClean="0"/>
+              <a:rPr lang="en-US"/>
               <a:t>Third level</a:t>
             </a:r>
           </a:p>
           <a:p>
             <a:pPr lvl="3"/>
             <a:r>
-              <a:rPr lang="en-US" smtClean="0"/>
+              <a:rPr lang="en-US"/>
               <a:t>Fourth level</a:t>
             </a:r>
           </a:p>
           <a:p>
             <a:pPr lvl="4"/>
             <a:r>
-              <a:rPr lang="en-US" smtClean="0"/>
+              <a:rPr lang="en-US"/>
               <a:t>Fifth level</a:t>
             </a:r>
-            <a:endParaRPr lang="en-US"/>
           </a:p>
         </p:txBody>
       </p:sp>
@@ -471,7 +483,7 @@
           <a:p>
             <a:fld id="{5BCAD085-E8A6-8845-BD4E-CB4CCA059FC4}" type="datetimeFigureOut">
               <a:rPr lang="en-US" smtClean="0"/>
-              <a:t>1/27/13</a:t>
+              <a:t>8/19/26</a:t>
             </a:fld>
             <a:endParaRPr lang="en-US"/>
           </a:p>
@@ -570,10 +582,9 @@
           <a:lstStyle/>
           <a:p>
             <a:r>
-              <a:rPr lang="en-US" smtClean="0"/>
+              <a:rPr lang="en-US"/>
               <a:t>Click to edit Master title style</a:t>
             </a:r>
-            <a:endParaRPr lang="en-US"/>
           </a:p>
         </p:txBody>
       </p:sp>
@@ -599,38 +610,37 @@
           <a:p>
             <a:pPr lvl="0"/>
             <a:r>
-              <a:rPr lang="en-US" smtClean="0"/>
+              <a:rPr lang="en-US"/>
               <a:t>Click to edit Master text styles</a:t>
             </a:r>
           </a:p>
           <a:p>
             <a:pPr lvl="1"/>
             <a:r>
-              <a:rPr lang="en-US" smtClean="0"/>
+              <a:rPr lang="en-US"/>
               <a:t>Second level</a:t>
             </a:r>
           </a:p>
           <a:p>
             <a:pPr lvl="2"/>
             <a:r>
-              <a:rPr lang="en-US" smtClean="0"/>
+              <a:rPr lang="en-US"/>
               <a:t>Third level</a:t>
             </a:r>
           </a:p>
           <a:p>
             <a:pPr lvl="3"/>
             <a:r>
-              <a:rPr lang="en-US" smtClean="0"/>
+              <a:rPr lang="en-US"/>
               <a:t>Fourth level</a:t>
             </a:r>
           </a:p>
           <a:p>
             <a:pPr lvl="4"/>
             <a:r>
-              <a:rPr lang="en-US" smtClean="0"/>
+              <a:rPr lang="en-US"/>
               <a:t>Fifth level</a:t>
             </a:r>
-            <a:endParaRPr lang="en-US"/>
           </a:p>
         </p:txBody>
       </p:sp>
@@ -651,7 +661,7 @@
           <a:p>
             <a:fld id="{5BCAD085-E8A6-8845-BD4E-CB4CCA059FC4}" type="datetimeFigureOut">
               <a:rPr lang="en-US" smtClean="0"/>
-              <a:t>1/27/13</a:t>
+              <a:t>8/19/26</a:t>
             </a:fld>
             <a:endParaRPr lang="en-US"/>
           </a:p>
@@ -745,10 +755,9 @@
           <a:lstStyle/>
           <a:p>
             <a:r>
-              <a:rPr lang="en-US" smtClean="0"/>
+              <a:rPr lang="en-US"/>
               <a:t>Click to edit Master title style</a:t>
             </a:r>
-            <a:endParaRPr lang="en-US"/>
           </a:p>
         </p:txBody>
       </p:sp>
@@ -769,38 +778,37 @@
           <a:p>
             <a:pPr lvl="0"/>
             <a:r>
-              <a:rPr lang="en-US" smtClean="0"/>
+              <a:rPr lang="en-US"/>
               <a:t>Click to edit Master text styles</a:t>
             </a:r>
           </a:p>
           <a:p>
             <a:pPr lvl="1"/>
             <a:r>
-              <a:rPr lang="en-US" smtClean="0"/>
+              <a:rPr lang="en-US"/>
               <a:t>Second level</a:t>
             </a:r>
           </a:p>
           <a:p>
             <a:pPr lvl="2"/>
             <a:r>
-              <a:rPr lang="en-US" smtClean="0"/>
+              <a:rPr lang="en-US"/>
               <a:t>Third level</a:t>
             </a:r>
           </a:p>
           <a:p>
             <a:pPr lvl="3"/>
             <a:r>
-              <a:rPr lang="en-US" smtClean="0"/>
+              <a:rPr lang="en-US"/>
               <a:t>Fourth level</a:t>
             </a:r>
           </a:p>
           <a:p>
             <a:pPr lvl="4"/>
             <a:r>
-              <a:rPr lang="en-US" smtClean="0"/>
+              <a:rPr lang="en-US"/>
               <a:t>Fifth level</a:t>
             </a:r>
-            <a:endParaRPr lang="en-US"/>
           </a:p>
         </p:txBody>
       </p:sp>
@@ -821,7 +829,7 @@
           <a:p>
             <a:fld id="{5BCAD085-E8A6-8845-BD4E-CB4CCA059FC4}" type="datetimeFigureOut">
               <a:rPr lang="en-US" smtClean="0"/>
-              <a:t>1/27/13</a:t>
+              <a:t>8/19/26</a:t>
             </a:fld>
             <a:endParaRPr lang="en-US"/>
           </a:p>
@@ -924,10 +932,9 @@
           </a:lstStyle>
           <a:p>
             <a:r>
-              <a:rPr lang="en-US" smtClean="0"/>
+              <a:rPr lang="en-US"/>
               <a:t>Click to edit Master title style</a:t>
             </a:r>
-            <a:endParaRPr lang="en-US"/>
           </a:p>
         </p:txBody>
       </p:sp>
@@ -1044,7 +1051,7 @@
           <a:p>
             <a:pPr lvl="0"/>
             <a:r>
-              <a:rPr lang="en-US" smtClean="0"/>
+              <a:rPr lang="en-US"/>
               <a:t>Click to edit Master text styles</a:t>
             </a:r>
           </a:p>
@@ -1067,7 +1074,7 @@
           <a:p>
             <a:fld id="{5BCAD085-E8A6-8845-BD4E-CB4CCA059FC4}" type="datetimeFigureOut">
               <a:rPr lang="en-US" smtClean="0"/>
-              <a:t>1/27/13</a:t>
+              <a:t>8/19/26</a:t>
             </a:fld>
             <a:endParaRPr lang="en-US"/>
           </a:p>
@@ -1161,10 +1168,9 @@
           <a:lstStyle/>
           <a:p>
             <a:r>
-              <a:rPr lang="en-US" smtClean="0"/>
+              <a:rPr lang="en-US"/>
               <a:t>Click to edit Master title style</a:t>
             </a:r>
-            <a:endParaRPr lang="en-US"/>
           </a:p>
         </p:txBody>
       </p:sp>
@@ -1218,38 +1224,37 @@
           <a:p>
             <a:pPr lvl="0"/>
             <a:r>
-              <a:rPr lang="en-US" smtClean="0"/>
+              <a:rPr lang="en-US"/>
               <a:t>Click to edit Master text styles</a:t>
             </a:r>
           </a:p>
           <a:p>
             <a:pPr lvl="1"/>
             <a:r>
-              <a:rPr lang="en-US" smtClean="0"/>
+              <a:rPr lang="en-US"/>
               <a:t>Second level</a:t>
             </a:r>
           </a:p>
           <a:p>
             <a:pPr lvl="2"/>
             <a:r>
-              <a:rPr lang="en-US" smtClean="0"/>
+              <a:rPr lang="en-US"/>
               <a:t>Third level</a:t>
             </a:r>
           </a:p>
           <a:p>
             <a:pPr lvl="3"/>
             <a:r>
-              <a:rPr lang="en-US" smtClean="0"/>
+              <a:rPr lang="en-US"/>
               <a:t>Fourth level</a:t>
             </a:r>
           </a:p>
           <a:p>
             <a:pPr lvl="4"/>
             <a:r>
-              <a:rPr lang="en-US" smtClean="0"/>
+              <a:rPr lang="en-US"/>
               <a:t>Fifth level</a:t>
             </a:r>
-            <a:endParaRPr lang="en-US"/>
           </a:p>
         </p:txBody>
       </p:sp>
@@ -1303,38 +1308,37 @@
           <a:p>
             <a:pPr lvl="0"/>
             <a:r>
-              <a:rPr lang="en-US" smtClean="0"/>
+              <a:rPr lang="en-US"/>
               <a:t>Click to edit Master text styles</a:t>
             </a:r>
           </a:p>
           <a:p>
             <a:pPr lvl="1"/>
             <a:r>
-              <a:rPr lang="en-US" smtClean="0"/>
+              <a:rPr lang="en-US"/>
               <a:t>Second level</a:t>
             </a:r>
           </a:p>
           <a:p>
             <a:pPr lvl="2"/>
             <a:r>
-              <a:rPr lang="en-US" smtClean="0"/>
+              <a:rPr lang="en-US"/>
               <a:t>Third level</a:t>
             </a:r>
           </a:p>
           <a:p>
             <a:pPr lvl="3"/>
             <a:r>
-              <a:rPr lang="en-US" smtClean="0"/>
+              <a:rPr lang="en-US"/>
               <a:t>Fourth level</a:t>
             </a:r>
           </a:p>
           <a:p>
             <a:pPr lvl="4"/>
             <a:r>
-              <a:rPr lang="en-US" smtClean="0"/>
+              <a:rPr lang="en-US"/>
               <a:t>Fifth level</a:t>
             </a:r>
-            <a:endParaRPr lang="en-US"/>
           </a:p>
         </p:txBody>
       </p:sp>
@@ -1355,7 +1359,7 @@
           <a:p>
             <a:fld id="{5BCAD085-E8A6-8845-BD4E-CB4CCA059FC4}" type="datetimeFigureOut">
               <a:rPr lang="en-US" smtClean="0"/>
-              <a:t>1/27/13</a:t>
+              <a:t>8/19/26</a:t>
             </a:fld>
             <a:endParaRPr lang="en-US"/>
           </a:p>
@@ -1453,10 +1457,9 @@
           </a:lstStyle>
           <a:p>
             <a:r>
-              <a:rPr lang="en-US" smtClean="0"/>
+              <a:rPr lang="en-US"/>
               <a:t>Click to edit Master title style</a:t>
             </a:r>
-            <a:endParaRPr lang="en-US"/>
           </a:p>
         </p:txBody>
       </p:sp>
@@ -1519,7 +1522,7 @@
           <a:p>
             <a:pPr lvl="0"/>
             <a:r>
-              <a:rPr lang="en-US" smtClean="0"/>
+              <a:rPr lang="en-US"/>
               <a:t>Click to edit Master text styles</a:t>
             </a:r>
           </a:p>
@@ -1575,38 +1578,37 @@
           <a:p>
             <a:pPr lvl="0"/>
             <a:r>
-              <a:rPr lang="en-US" smtClean="0"/>
+              <a:rPr lang="en-US"/>
               <a:t>Click to edit Master text styles</a:t>
             </a:r>
           </a:p>
           <a:p>
             <a:pPr lvl="1"/>
             <a:r>
-              <a:rPr lang="en-US" smtClean="0"/>
+              <a:rPr lang="en-US"/>
               <a:t>Second level</a:t>
             </a:r>
           </a:p>
           <a:p>
             <a:pPr lvl="2"/>
             <a:r>
-              <a:rPr lang="en-US" smtClean="0"/>
+              <a:rPr lang="en-US"/>
               <a:t>Third level</a:t>
             </a:r>
           </a:p>
           <a:p>
             <a:pPr lvl="3"/>
             <a:r>
-              <a:rPr lang="en-US" smtClean="0"/>
+              <a:rPr lang="en-US"/>
               <a:t>Fourth level</a:t>
             </a:r>
           </a:p>
           <a:p>
             <a:pPr lvl="4"/>
             <a:r>
-              <a:rPr lang="en-US" smtClean="0"/>
+              <a:rPr lang="en-US"/>
               <a:t>Fifth level</a:t>
             </a:r>
-            <a:endParaRPr lang="en-US"/>
           </a:p>
         </p:txBody>
       </p:sp>
@@ -1669,7 +1671,7 @@
           <a:p>
             <a:pPr lvl="0"/>
             <a:r>
-              <a:rPr lang="en-US" smtClean="0"/>
+              <a:rPr lang="en-US"/>
               <a:t>Click to edit Master text styles</a:t>
             </a:r>
           </a:p>
@@ -1725,38 +1727,37 @@
           <a:p>
             <a:pPr lvl="0"/>
             <a:r>
-              <a:rPr lang="en-US" smtClean="0"/>
+              <a:rPr lang="en-US"/>
               <a:t>Click to edit Master text styles</a:t>
             </a:r>
           </a:p>
           <a:p>
             <a:pPr lvl="1"/>
             <a:r>
-              <a:rPr lang="en-US" smtClean="0"/>
+              <a:rPr lang="en-US"/>
               <a:t>Second level</a:t>
             </a:r>
           </a:p>
           <a:p>
             <a:pPr lvl="2"/>
             <a:r>
-              <a:rPr lang="en-US" smtClean="0"/>
+              <a:rPr lang="en-US"/>
               <a:t>Third level</a:t>
             </a:r>
           </a:p>
           <a:p>
             <a:pPr lvl="3"/>
             <a:r>
-              <a:rPr lang="en-US" smtClean="0"/>
+              <a:rPr lang="en-US"/>
               <a:t>Fourth level</a:t>
             </a:r>
           </a:p>
           <a:p>
             <a:pPr lvl="4"/>
             <a:r>
-              <a:rPr lang="en-US" smtClean="0"/>
+              <a:rPr lang="en-US"/>
               <a:t>Fifth level</a:t>
             </a:r>
-            <a:endParaRPr lang="en-US"/>
           </a:p>
         </p:txBody>
       </p:sp>
@@ -1777,7 +1778,7 @@
           <a:p>
             <a:fld id="{5BCAD085-E8A6-8845-BD4E-CB4CCA059FC4}" type="datetimeFigureOut">
               <a:rPr lang="en-US" smtClean="0"/>
-              <a:t>1/27/13</a:t>
+              <a:t>8/19/26</a:t>
             </a:fld>
             <a:endParaRPr lang="en-US"/>
           </a:p>
@@ -1871,10 +1872,9 @@
           <a:lstStyle/>
           <a:p>
             <a:r>
-              <a:rPr lang="en-US" smtClean="0"/>
+              <a:rPr lang="en-US"/>
               <a:t>Click to edit Master title style</a:t>
             </a:r>
-            <a:endParaRPr lang="en-US"/>
           </a:p>
         </p:txBody>
       </p:sp>
@@ -1895,7 +1895,7 @@
           <a:p>
             <a:fld id="{5BCAD085-E8A6-8845-BD4E-CB4CCA059FC4}" type="datetimeFigureOut">
               <a:rPr lang="en-US" smtClean="0"/>
-              <a:t>1/27/13</a:t>
+              <a:t>8/19/26</a:t>
             </a:fld>
             <a:endParaRPr lang="en-US"/>
           </a:p>
@@ -1990,7 +1990,7 @@
           <a:p>
             <a:fld id="{5BCAD085-E8A6-8845-BD4E-CB4CCA059FC4}" type="datetimeFigureOut">
               <a:rPr lang="en-US" smtClean="0"/>
-              <a:t>1/27/13</a:t>
+              <a:t>8/19/26</a:t>
             </a:fld>
             <a:endParaRPr lang="en-US"/>
           </a:p>
@@ -2093,10 +2093,9 @@
           </a:lstStyle>
           <a:p>
             <a:r>
-              <a:rPr lang="en-US" smtClean="0"/>
+              <a:rPr lang="en-US"/>
               <a:t>Click to edit Master title style</a:t>
             </a:r>
-            <a:endParaRPr lang="en-US"/>
           </a:p>
         </p:txBody>
       </p:sp>
@@ -2150,38 +2149,37 @@
           <a:p>
             <a:pPr lvl="0"/>
             <a:r>
-              <a:rPr lang="en-US" smtClean="0"/>
+              <a:rPr lang="en-US"/>
               <a:t>Click to edit Master text styles</a:t>
             </a:r>
           </a:p>
           <a:p>
             <a:pPr lvl="1"/>
             <a:r>
-              <a:rPr lang="en-US" smtClean="0"/>
+              <a:rPr lang="en-US"/>
               <a:t>Second level</a:t>
             </a:r>
           </a:p>
           <a:p>
             <a:pPr lvl="2"/>
             <a:r>
-              <a:rPr lang="en-US" smtClean="0"/>
+              <a:rPr lang="en-US"/>
               <a:t>Third level</a:t>
             </a:r>
           </a:p>
           <a:p>
             <a:pPr lvl="3"/>
             <a:r>
-              <a:rPr lang="en-US" smtClean="0"/>
+              <a:rPr lang="en-US"/>
               <a:t>Fourth level</a:t>
             </a:r>
           </a:p>
           <a:p>
             <a:pPr lvl="4"/>
             <a:r>
-              <a:rPr lang="en-US" smtClean="0"/>
+              <a:rPr lang="en-US"/>
               <a:t>Fifth level</a:t>
             </a:r>
-            <a:endParaRPr lang="en-US"/>
           </a:p>
         </p:txBody>
       </p:sp>
@@ -2244,7 +2242,7 @@
           <a:p>
             <a:pPr lvl="0"/>
             <a:r>
-              <a:rPr lang="en-US" smtClean="0"/>
+              <a:rPr lang="en-US"/>
               <a:t>Click to edit Master text styles</a:t>
             </a:r>
           </a:p>
@@ -2267,7 +2265,7 @@
           <a:p>
             <a:fld id="{5BCAD085-E8A6-8845-BD4E-CB4CCA059FC4}" type="datetimeFigureOut">
               <a:rPr lang="en-US" smtClean="0"/>
-              <a:t>1/27/13</a:t>
+              <a:t>8/19/26</a:t>
             </a:fld>
             <a:endParaRPr lang="en-US"/>
           </a:p>
@@ -2370,10 +2368,9 @@
           </a:lstStyle>
           <a:p>
             <a:r>
-              <a:rPr lang="en-US" smtClean="0"/>
+              <a:rPr lang="en-US"/>
               <a:t>Click to edit Master title style</a:t>
             </a:r>
-            <a:endParaRPr lang="en-US"/>
           </a:p>
         </p:txBody>
       </p:sp>
@@ -2497,7 +2494,7 @@
           <a:p>
             <a:pPr lvl="0"/>
             <a:r>
-              <a:rPr lang="en-US" smtClean="0"/>
+              <a:rPr lang="en-US"/>
               <a:t>Click to edit Master text styles</a:t>
             </a:r>
           </a:p>
@@ -2520,7 +2517,7 @@
           <a:p>
             <a:fld id="{5BCAD085-E8A6-8845-BD4E-CB4CCA059FC4}" type="datetimeFigureOut">
               <a:rPr lang="en-US" smtClean="0"/>
-              <a:t>1/27/13</a:t>
+              <a:t>8/19/26</a:t>
             </a:fld>
             <a:endParaRPr lang="en-US"/>
           </a:p>
@@ -2629,10 +2626,9 @@
           <a:lstStyle/>
           <a:p>
             <a:r>
-              <a:rPr lang="en-US" smtClean="0"/>
+              <a:rPr lang="en-US"/>
               <a:t>Click to edit Master title style</a:t>
             </a:r>
-            <a:endParaRPr lang="en-US"/>
           </a:p>
         </p:txBody>
       </p:sp>
@@ -2663,38 +2659,37 @@
           <a:p>
             <a:pPr lvl="0"/>
             <a:r>
-              <a:rPr lang="en-US" smtClean="0"/>
+              <a:rPr lang="en-US"/>
               <a:t>Click to edit Master text styles</a:t>
             </a:r>
           </a:p>
           <a:p>
             <a:pPr lvl="1"/>
             <a:r>
-              <a:rPr lang="en-US" smtClean="0"/>
+              <a:rPr lang="en-US"/>
               <a:t>Second level</a:t>
             </a:r>
           </a:p>
           <a:p>
             <a:pPr lvl="2"/>
             <a:r>
-              <a:rPr lang="en-US" smtClean="0"/>
+              <a:rPr lang="en-US"/>
               <a:t>Third level</a:t>
             </a:r>
           </a:p>
           <a:p>
             <a:pPr lvl="3"/>
             <a:r>
-              <a:rPr lang="en-US" smtClean="0"/>
+              <a:rPr lang="en-US"/>
               <a:t>Fourth level</a:t>
             </a:r>
           </a:p>
           <a:p>
             <a:pPr lvl="4"/>
             <a:r>
-              <a:rPr lang="en-US" smtClean="0"/>
+              <a:rPr lang="en-US"/>
               <a:t>Fifth level</a:t>
             </a:r>
-            <a:endParaRPr lang="en-US"/>
           </a:p>
         </p:txBody>
       </p:sp>
@@ -2733,7 +2728,7 @@
           <a:p>
             <a:fld id="{5BCAD085-E8A6-8845-BD4E-CB4CCA059FC4}" type="datetimeFigureOut">
               <a:rPr lang="en-US" smtClean="0"/>
-              <a:t>1/27/13</a:t>
+              <a:t>8/19/26</a:t>
             </a:fld>
             <a:endParaRPr lang="en-US"/>
           </a:p>
@@ -3092,7 +3087,7 @@
 </file>
 
 <file path=ppt/slides/slide1.xml><?xml version="1.0" encoding="utf-8"?>
-<p:sld xmlns:a="http://schemas.openxmlformats.org/drawingml/2006/main" xmlns:p="http://schemas.openxmlformats.org/presentationml/2006/main" xmlns:r="http://schemas.openxmlformats.org/officeDocument/2006/relationships">
+<p:sld xmlns:a="http://schemas.openxmlformats.org/drawingml/2006/main" xmlns:r="http://schemas.openxmlformats.org/officeDocument/2006/relationships" xmlns:p="http://schemas.openxmlformats.org/presentationml/2006/main">
   <p:cSld>
     <p:spTree>
       <p:nvGrpSpPr>
@@ -3100,7 +3095,14 @@
         <p:cNvGrpSpPr/>
         <p:nvPr/>
       </p:nvGrpSpPr>
-      <p:grpSpPr/>
+      <p:grpSpPr>
+        <a:xfrm>
+          <a:off x="0" y="0"/>
+          <a:ext cx="0" cy="0"/>
+          <a:chOff x="0" y="0"/>
+          <a:chExt cx="0" cy="0"/>
+        </a:xfrm>
+      </p:grpSpPr>
       <p:sp>
         <p:nvSpPr>
           <p:cNvPr id="2" name="Rectangle 1"/>
@@ -3141,6 +3143,7 @@
           <a:lstStyle/>
           <a:p>
             <a:pPr algn="ctr"/>
+            <a:endParaRPr/>
           </a:p>
         </p:txBody>
       </p:sp>
@@ -3184,6 +3187,7 @@
           <a:lstStyle/>
           <a:p>
             <a:pPr algn="ctr"/>
+            <a:endParaRPr/>
           </a:p>
         </p:txBody>
       </p:sp>
@@ -3305,7 +3309,7 @@
               </a:defRPr>
             </a:pPr>
             <a:r>
-              <a:t>Presented by: Product &amp; Engineering Leadership  |  Confidential  |  v2.0 Production Ready</a:t>
+              <a:t>Presented by: Product &amp; Engineering Leadership  |  Confidential  |  v2.5 Production Ready</a:t>
             </a:r>
           </a:p>
         </p:txBody>
@@ -3319,7 +3323,7 @@
 </file>
 
 <file path=ppt/slides/slide10.xml><?xml version="1.0" encoding="utf-8"?>
-<p:sld xmlns:a="http://schemas.openxmlformats.org/drawingml/2006/main" xmlns:p="http://schemas.openxmlformats.org/presentationml/2006/main" xmlns:r="http://schemas.openxmlformats.org/officeDocument/2006/relationships">
+<p:sld xmlns:a="http://schemas.openxmlformats.org/drawingml/2006/main" xmlns:r="http://schemas.openxmlformats.org/officeDocument/2006/relationships" xmlns:p="http://schemas.openxmlformats.org/presentationml/2006/main">
   <p:cSld>
     <p:spTree>
       <p:nvGrpSpPr>
@@ -3327,7 +3331,14 @@
         <p:cNvGrpSpPr/>
         <p:nvPr/>
       </p:nvGrpSpPr>
-      <p:grpSpPr/>
+      <p:grpSpPr>
+        <a:xfrm>
+          <a:off x="0" y="0"/>
+          <a:ext cx="0" cy="0"/>
+          <a:chOff x="0" y="0"/>
+          <a:chExt cx="0" cy="0"/>
+        </a:xfrm>
+      </p:grpSpPr>
       <p:sp>
         <p:nvSpPr>
           <p:cNvPr id="2" name="Rectangle 1"/>
@@ -3368,6 +3379,7 @@
           <a:lstStyle/>
           <a:p>
             <a:pPr algn="ctr"/>
+            <a:endParaRPr/>
           </a:p>
         </p:txBody>
       </p:sp>
@@ -3388,7 +3400,7 @@
           <a:noFill/>
         </p:spPr>
         <p:txBody>
-          <a:bodyPr wrap="square" lIns="0" rIns="0" tIns="0" bIns="0">
+          <a:bodyPr wrap="square" lIns="0" tIns="0" rIns="0" bIns="0">
             <a:spAutoFit/>
           </a:bodyPr>
           <a:lstStyle/>
@@ -3424,7 +3436,7 @@
           <a:noFill/>
         </p:spPr>
         <p:txBody>
-          <a:bodyPr wrap="square" lIns="0" rIns="0" tIns="0" bIns="0">
+          <a:bodyPr wrap="square" lIns="0" tIns="0" rIns="0" bIns="0">
             <a:spAutoFit/>
           </a:bodyPr>
           <a:lstStyle/>
@@ -3483,6 +3495,7 @@
           <a:lstStyle/>
           <a:p>
             <a:pPr algn="ctr"/>
+            <a:endParaRPr/>
           </a:p>
         </p:txBody>
       </p:sp>
@@ -3503,7 +3516,7 @@
           <a:noFill/>
         </p:spPr>
         <p:txBody>
-          <a:bodyPr wrap="none" lIns="0" rIns="0" tIns="0" bIns="0">
+          <a:bodyPr wrap="none" lIns="0" tIns="0" rIns="0" bIns="0">
             <a:spAutoFit/>
           </a:bodyPr>
           <a:lstStyle/>
@@ -3564,6 +3577,7 @@
           <a:lstStyle/>
           <a:p>
             <a:pPr algn="ctr"/>
+            <a:endParaRPr/>
           </a:p>
         </p:txBody>
       </p:sp>
@@ -3584,7 +3598,7 @@
           <a:noFill/>
         </p:spPr>
         <p:txBody>
-          <a:bodyPr wrap="square" lIns="0" rIns="0" tIns="0" bIns="0">
+          <a:bodyPr wrap="square" lIns="0" tIns="0" rIns="0" bIns="0">
             <a:spAutoFit/>
           </a:bodyPr>
           <a:lstStyle/>
@@ -3630,7 +3644,7 @@
               </a:defRPr>
             </a:pPr>
             <a:r>
-              <a:t>• Targeted role-based WebSocket connections with sub-second alert delivery.</a:t>
+              <a:t>• Targeted role-based WebSocket connections with sub-second alert delivery and Web Audio chimes.</a:t>
             </a:r>
           </a:p>
           <a:p>
@@ -3646,7 +3660,7 @@
               </a:defRPr>
             </a:pPr>
             <a:r>
-              <a:t>• Client reconnection backoff algorithm with automatic token heartbeat.</a:t>
+              <a:t>• Client reconnection backoff algorithm with automatic token heartbeat and floating toast stack.</a:t>
             </a:r>
           </a:p>
         </p:txBody>
@@ -3693,6 +3707,7 @@
           <a:lstStyle/>
           <a:p>
             <a:pPr algn="ctr"/>
+            <a:endParaRPr/>
           </a:p>
         </p:txBody>
       </p:sp>
@@ -3713,7 +3728,7 @@
           <a:noFill/>
         </p:spPr>
         <p:txBody>
-          <a:bodyPr wrap="square" lIns="0" rIns="0" tIns="0" bIns="0">
+          <a:bodyPr wrap="square" lIns="0" tIns="0" rIns="0" bIns="0">
             <a:spAutoFit/>
           </a:bodyPr>
           <a:lstStyle/>
@@ -3822,6 +3837,7 @@
           <a:lstStyle/>
           <a:p>
             <a:pPr algn="ctr"/>
+            <a:endParaRPr/>
           </a:p>
         </p:txBody>
       </p:sp>
@@ -3842,7 +3858,7 @@
           <a:noFill/>
         </p:spPr>
         <p:txBody>
-          <a:bodyPr wrap="square" lIns="0" rIns="0" tIns="0" bIns="0">
+          <a:bodyPr wrap="square" lIns="0" tIns="0" rIns="0" bIns="0">
             <a:spAutoFit/>
           </a:bodyPr>
           <a:lstStyle/>
@@ -3918,7 +3934,7 @@
 </file>
 
 <file path=ppt/slides/slide11.xml><?xml version="1.0" encoding="utf-8"?>
-<p:sld xmlns:a="http://schemas.openxmlformats.org/drawingml/2006/main" xmlns:p="http://schemas.openxmlformats.org/presentationml/2006/main" xmlns:r="http://schemas.openxmlformats.org/officeDocument/2006/relationships">
+<p:sld xmlns:a="http://schemas.openxmlformats.org/drawingml/2006/main" xmlns:r="http://schemas.openxmlformats.org/officeDocument/2006/relationships" xmlns:p="http://schemas.openxmlformats.org/presentationml/2006/main">
   <p:cSld>
     <p:spTree>
       <p:nvGrpSpPr>
@@ -3926,7 +3942,14 @@
         <p:cNvGrpSpPr/>
         <p:nvPr/>
       </p:nvGrpSpPr>
-      <p:grpSpPr/>
+      <p:grpSpPr>
+        <a:xfrm>
+          <a:off x="0" y="0"/>
+          <a:ext cx="0" cy="0"/>
+          <a:chOff x="0" y="0"/>
+          <a:chExt cx="0" cy="0"/>
+        </a:xfrm>
+      </p:grpSpPr>
       <p:sp>
         <p:nvSpPr>
           <p:cNvPr id="2" name="Rectangle 1"/>
@@ -3967,6 +3990,7 @@
           <a:lstStyle/>
           <a:p>
             <a:pPr algn="ctr"/>
+            <a:endParaRPr/>
           </a:p>
         </p:txBody>
       </p:sp>
@@ -3987,7 +4011,7 @@
           <a:noFill/>
         </p:spPr>
         <p:txBody>
-          <a:bodyPr wrap="square" lIns="0" rIns="0" tIns="0" bIns="0">
+          <a:bodyPr wrap="square" lIns="0" tIns="0" rIns="0" bIns="0">
             <a:spAutoFit/>
           </a:bodyPr>
           <a:lstStyle/>
@@ -4023,7 +4047,7 @@
           <a:noFill/>
         </p:spPr>
         <p:txBody>
-          <a:bodyPr wrap="square" lIns="0" rIns="0" tIns="0" bIns="0">
+          <a:bodyPr wrap="square" lIns="0" tIns="0" rIns="0" bIns="0">
             <a:spAutoFit/>
           </a:bodyPr>
           <a:lstStyle/>
@@ -4082,6 +4106,7 @@
           <a:lstStyle/>
           <a:p>
             <a:pPr algn="ctr"/>
+            <a:endParaRPr/>
           </a:p>
         </p:txBody>
       </p:sp>
@@ -4102,7 +4127,7 @@
           <a:noFill/>
         </p:spPr>
         <p:txBody>
-          <a:bodyPr wrap="none" lIns="0" rIns="0" tIns="0" bIns="0">
+          <a:bodyPr wrap="none" lIns="0" tIns="0" rIns="0" bIns="0">
             <a:spAutoFit/>
           </a:bodyPr>
           <a:lstStyle/>
@@ -4163,6 +4188,7 @@
           <a:lstStyle/>
           <a:p>
             <a:pPr algn="ctr"/>
+            <a:endParaRPr/>
           </a:p>
         </p:txBody>
       </p:sp>
@@ -4183,7 +4209,7 @@
           <a:noFill/>
         </p:spPr>
         <p:txBody>
-          <a:bodyPr wrap="square" lIns="0" rIns="0" tIns="0" bIns="0">
+          <a:bodyPr wrap="square" lIns="0" tIns="0" rIns="0" bIns="0">
             <a:spAutoFit/>
           </a:bodyPr>
           <a:lstStyle/>
@@ -4292,6 +4318,7 @@
           <a:lstStyle/>
           <a:p>
             <a:pPr algn="ctr"/>
+            <a:endParaRPr/>
           </a:p>
         </p:txBody>
       </p:sp>
@@ -4312,7 +4339,7 @@
           <a:noFill/>
         </p:spPr>
         <p:txBody>
-          <a:bodyPr wrap="square" lIns="0" rIns="0" tIns="0" bIns="0">
+          <a:bodyPr wrap="square" lIns="0" tIns="0" rIns="0" bIns="0">
             <a:spAutoFit/>
           </a:bodyPr>
           <a:lstStyle/>
@@ -4421,6 +4448,7 @@
           <a:lstStyle/>
           <a:p>
             <a:pPr algn="ctr"/>
+            <a:endParaRPr/>
           </a:p>
         </p:txBody>
       </p:sp>
@@ -4441,7 +4469,7 @@
           <a:noFill/>
         </p:spPr>
         <p:txBody>
-          <a:bodyPr wrap="square" lIns="0" rIns="0" tIns="0" bIns="0">
+          <a:bodyPr wrap="square" lIns="0" tIns="0" rIns="0" bIns="0">
             <a:spAutoFit/>
           </a:bodyPr>
           <a:lstStyle/>
@@ -4517,7 +4545,7 @@
 </file>
 
 <file path=ppt/slides/slide12.xml><?xml version="1.0" encoding="utf-8"?>
-<p:sld xmlns:a="http://schemas.openxmlformats.org/drawingml/2006/main" xmlns:p="http://schemas.openxmlformats.org/presentationml/2006/main" xmlns:r="http://schemas.openxmlformats.org/officeDocument/2006/relationships">
+<p:sld xmlns:a="http://schemas.openxmlformats.org/drawingml/2006/main" xmlns:r="http://schemas.openxmlformats.org/officeDocument/2006/relationships" xmlns:p="http://schemas.openxmlformats.org/presentationml/2006/main">
   <p:cSld>
     <p:spTree>
       <p:nvGrpSpPr>
@@ -4525,7 +4553,14 @@
         <p:cNvGrpSpPr/>
         <p:nvPr/>
       </p:nvGrpSpPr>
-      <p:grpSpPr/>
+      <p:grpSpPr>
+        <a:xfrm>
+          <a:off x="0" y="0"/>
+          <a:ext cx="0" cy="0"/>
+          <a:chOff x="0" y="0"/>
+          <a:chExt cx="0" cy="0"/>
+        </a:xfrm>
+      </p:grpSpPr>
       <p:sp>
         <p:nvSpPr>
           <p:cNvPr id="2" name="Rectangle 1"/>
@@ -4566,6 +4601,7 @@
           <a:lstStyle/>
           <a:p>
             <a:pPr algn="ctr"/>
+            <a:endParaRPr/>
           </a:p>
         </p:txBody>
       </p:sp>
@@ -4586,7 +4622,7 @@
           <a:noFill/>
         </p:spPr>
         <p:txBody>
-          <a:bodyPr wrap="square" lIns="0" rIns="0" tIns="0" bIns="0">
+          <a:bodyPr wrap="square" lIns="0" tIns="0" rIns="0" bIns="0">
             <a:spAutoFit/>
           </a:bodyPr>
           <a:lstStyle/>
@@ -4622,7 +4658,7 @@
           <a:noFill/>
         </p:spPr>
         <p:txBody>
-          <a:bodyPr wrap="square" lIns="0" rIns="0" tIns="0" bIns="0">
+          <a:bodyPr wrap="square" lIns="0" tIns="0" rIns="0" bIns="0">
             <a:spAutoFit/>
           </a:bodyPr>
           <a:lstStyle/>
@@ -4681,6 +4717,7 @@
           <a:lstStyle/>
           <a:p>
             <a:pPr algn="ctr"/>
+            <a:endParaRPr/>
           </a:p>
         </p:txBody>
       </p:sp>
@@ -4701,7 +4738,7 @@
           <a:noFill/>
         </p:spPr>
         <p:txBody>
-          <a:bodyPr wrap="none" lIns="0" rIns="0" tIns="0" bIns="0">
+          <a:bodyPr wrap="none" lIns="0" tIns="0" rIns="0" bIns="0">
             <a:spAutoFit/>
           </a:bodyPr>
           <a:lstStyle/>
@@ -4762,6 +4799,7 @@
           <a:lstStyle/>
           <a:p>
             <a:pPr algn="ctr"/>
+            <a:endParaRPr/>
           </a:p>
         </p:txBody>
       </p:sp>
@@ -4875,6 +4913,7 @@
           <a:lstStyle/>
           <a:p>
             <a:pPr algn="ctr"/>
+            <a:endParaRPr/>
           </a:p>
         </p:txBody>
       </p:sp>
@@ -4988,6 +5027,7 @@
           <a:lstStyle/>
           <a:p>
             <a:pPr algn="ctr"/>
+            <a:endParaRPr/>
           </a:p>
         </p:txBody>
       </p:sp>
@@ -5101,6 +5141,7 @@
           <a:lstStyle/>
           <a:p>
             <a:pPr algn="ctr"/>
+            <a:endParaRPr/>
           </a:p>
         </p:txBody>
       </p:sp>
@@ -5181,7 +5222,7 @@
 </file>
 
 <file path=ppt/slides/slide13.xml><?xml version="1.0" encoding="utf-8"?>
-<p:sld xmlns:a="http://schemas.openxmlformats.org/drawingml/2006/main" xmlns:p="http://schemas.openxmlformats.org/presentationml/2006/main" xmlns:r="http://schemas.openxmlformats.org/officeDocument/2006/relationships">
+<p:sld xmlns:a="http://schemas.openxmlformats.org/drawingml/2006/main" xmlns:r="http://schemas.openxmlformats.org/officeDocument/2006/relationships" xmlns:p="http://schemas.openxmlformats.org/presentationml/2006/main">
   <p:cSld>
     <p:spTree>
       <p:nvGrpSpPr>
@@ -5189,7 +5230,14 @@
         <p:cNvGrpSpPr/>
         <p:nvPr/>
       </p:nvGrpSpPr>
-      <p:grpSpPr/>
+      <p:grpSpPr>
+        <a:xfrm>
+          <a:off x="0" y="0"/>
+          <a:ext cx="0" cy="0"/>
+          <a:chOff x="0" y="0"/>
+          <a:chExt cx="0" cy="0"/>
+        </a:xfrm>
+      </p:grpSpPr>
       <p:sp>
         <p:nvSpPr>
           <p:cNvPr id="2" name="Rectangle 1"/>
@@ -5230,6 +5278,7 @@
           <a:lstStyle/>
           <a:p>
             <a:pPr algn="ctr"/>
+            <a:endParaRPr/>
           </a:p>
         </p:txBody>
       </p:sp>
@@ -5250,7 +5299,7 @@
           <a:noFill/>
         </p:spPr>
         <p:txBody>
-          <a:bodyPr wrap="square" lIns="0" rIns="0" tIns="0" bIns="0">
+          <a:bodyPr wrap="square" lIns="0" tIns="0" rIns="0" bIns="0">
             <a:spAutoFit/>
           </a:bodyPr>
           <a:lstStyle/>
@@ -5286,7 +5335,7 @@
           <a:noFill/>
         </p:spPr>
         <p:txBody>
-          <a:bodyPr wrap="square" lIns="0" rIns="0" tIns="0" bIns="0">
+          <a:bodyPr wrap="square" lIns="0" tIns="0" rIns="0" bIns="0">
             <a:spAutoFit/>
           </a:bodyPr>
           <a:lstStyle/>
@@ -5345,6 +5394,7 @@
           <a:lstStyle/>
           <a:p>
             <a:pPr algn="ctr"/>
+            <a:endParaRPr/>
           </a:p>
         </p:txBody>
       </p:sp>
@@ -5365,7 +5415,7 @@
           <a:noFill/>
         </p:spPr>
         <p:txBody>
-          <a:bodyPr wrap="none" lIns="0" rIns="0" tIns="0" bIns="0">
+          <a:bodyPr wrap="none" lIns="0" tIns="0" rIns="0" bIns="0">
             <a:spAutoFit/>
           </a:bodyPr>
           <a:lstStyle/>
@@ -5426,6 +5476,7 @@
           <a:lstStyle/>
           <a:p>
             <a:pPr algn="ctr"/>
+            <a:endParaRPr/>
           </a:p>
         </p:txBody>
       </p:sp>
@@ -5446,7 +5497,7 @@
           <a:noFill/>
         </p:spPr>
         <p:txBody>
-          <a:bodyPr wrap="square" lIns="0" rIns="0" tIns="0" bIns="0">
+          <a:bodyPr wrap="square" lIns="0" tIns="0" rIns="0" bIns="0">
             <a:spAutoFit/>
           </a:bodyPr>
           <a:lstStyle/>
@@ -5460,7 +5511,7 @@
               </a:defRPr>
             </a:pPr>
             <a:r>
-              <a:t>Phase 1: Current Release (v2.0 Production)</a:t>
+              <a:t>Phase 1: Current Release (v2.5 Production)</a:t>
             </a:r>
           </a:p>
           <a:p>
@@ -5492,7 +5543,23 @@
               </a:defRPr>
             </a:pPr>
             <a:r>
-              <a:t>• 10-second real-time cross-device sync &amp; WebSocket alerts.</a:t>
+              <a:t>• Pre-DCR order editing and safe cancellation engine.</a:t>
+            </a:r>
+          </a:p>
+          <a:p>
+            <a:pPr>
+              <a:spcBef>
+                <a:spcPts val="400"/>
+              </a:spcBef>
+              <a:defRPr sz="1000">
+                <a:solidFill>
+                  <a:srgbClr val="F8FAFC"/>
+                </a:solidFill>
+                <a:latin typeface="Arial"/>
+              </a:defRPr>
+            </a:pPr>
+            <a:r>
+              <a:t>• 1-Click live presentation role switcher dock &amp; toasts.</a:t>
             </a:r>
           </a:p>
           <a:p>
@@ -5571,6 +5638,7 @@
           <a:lstStyle/>
           <a:p>
             <a:pPr algn="ctr"/>
+            <a:endParaRPr/>
           </a:p>
         </p:txBody>
       </p:sp>
@@ -5591,7 +5659,7 @@
           <a:noFill/>
         </p:spPr>
         <p:txBody>
-          <a:bodyPr wrap="square" lIns="0" rIns="0" tIns="0" bIns="0">
+          <a:bodyPr wrap="square" lIns="0" tIns="0" rIns="0" bIns="0">
             <a:spAutoFit/>
           </a:bodyPr>
           <a:lstStyle/>
@@ -5716,6 +5784,7 @@
           <a:lstStyle/>
           <a:p>
             <a:pPr algn="ctr"/>
+            <a:endParaRPr/>
           </a:p>
         </p:txBody>
       </p:sp>
@@ -5736,7 +5805,7 @@
           <a:noFill/>
         </p:spPr>
         <p:txBody>
-          <a:bodyPr wrap="square" lIns="0" rIns="0" tIns="0" bIns="0">
+          <a:bodyPr wrap="square" lIns="0" tIns="0" rIns="0" bIns="0">
             <a:spAutoFit/>
           </a:bodyPr>
           <a:lstStyle/>
@@ -5828,7 +5897,7 @@
 </file>
 
 <file path=ppt/slides/slide14.xml><?xml version="1.0" encoding="utf-8"?>
-<p:sld xmlns:a="http://schemas.openxmlformats.org/drawingml/2006/main" xmlns:p="http://schemas.openxmlformats.org/presentationml/2006/main" xmlns:r="http://schemas.openxmlformats.org/officeDocument/2006/relationships">
+<p:sld xmlns:a="http://schemas.openxmlformats.org/drawingml/2006/main" xmlns:r="http://schemas.openxmlformats.org/officeDocument/2006/relationships" xmlns:p="http://schemas.openxmlformats.org/presentationml/2006/main">
   <p:cSld>
     <p:spTree>
       <p:nvGrpSpPr>
@@ -5836,7 +5905,14 @@
         <p:cNvGrpSpPr/>
         <p:nvPr/>
       </p:nvGrpSpPr>
-      <p:grpSpPr/>
+      <p:grpSpPr>
+        <a:xfrm>
+          <a:off x="0" y="0"/>
+          <a:ext cx="0" cy="0"/>
+          <a:chOff x="0" y="0"/>
+          <a:chExt cx="0" cy="0"/>
+        </a:xfrm>
+      </p:grpSpPr>
       <p:sp>
         <p:nvSpPr>
           <p:cNvPr id="2" name="Rectangle 1"/>
@@ -5877,6 +5953,7 @@
           <a:lstStyle/>
           <a:p>
             <a:pPr algn="ctr"/>
+            <a:endParaRPr/>
           </a:p>
         </p:txBody>
       </p:sp>
@@ -5920,6 +5997,7 @@
           <a:lstStyle/>
           <a:p>
             <a:pPr algn="ctr"/>
+            <a:endParaRPr/>
           </a:p>
         </p:txBody>
       </p:sp>
@@ -6012,7 +6090,7 @@
 </file>
 
 <file path=ppt/slides/slide2.xml><?xml version="1.0" encoding="utf-8"?>
-<p:sld xmlns:a="http://schemas.openxmlformats.org/drawingml/2006/main" xmlns:p="http://schemas.openxmlformats.org/presentationml/2006/main" xmlns:r="http://schemas.openxmlformats.org/officeDocument/2006/relationships">
+<p:sld xmlns:a="http://schemas.openxmlformats.org/drawingml/2006/main" xmlns:r="http://schemas.openxmlformats.org/officeDocument/2006/relationships" xmlns:p="http://schemas.openxmlformats.org/presentationml/2006/main">
   <p:cSld>
     <p:spTree>
       <p:nvGrpSpPr>
@@ -6020,7 +6098,14 @@
         <p:cNvGrpSpPr/>
         <p:nvPr/>
       </p:nvGrpSpPr>
-      <p:grpSpPr/>
+      <p:grpSpPr>
+        <a:xfrm>
+          <a:off x="0" y="0"/>
+          <a:ext cx="0" cy="0"/>
+          <a:chOff x="0" y="0"/>
+          <a:chExt cx="0" cy="0"/>
+        </a:xfrm>
+      </p:grpSpPr>
       <p:sp>
         <p:nvSpPr>
           <p:cNvPr id="2" name="Rectangle 1"/>
@@ -6061,6 +6146,7 @@
           <a:lstStyle/>
           <a:p>
             <a:pPr algn="ctr"/>
+            <a:endParaRPr/>
           </a:p>
         </p:txBody>
       </p:sp>
@@ -6081,7 +6167,7 @@
           <a:noFill/>
         </p:spPr>
         <p:txBody>
-          <a:bodyPr wrap="square" lIns="0" rIns="0" tIns="0" bIns="0">
+          <a:bodyPr wrap="square" lIns="0" tIns="0" rIns="0" bIns="0">
             <a:spAutoFit/>
           </a:bodyPr>
           <a:lstStyle/>
@@ -6117,7 +6203,7 @@
           <a:noFill/>
         </p:spPr>
         <p:txBody>
-          <a:bodyPr wrap="square" lIns="0" rIns="0" tIns="0" bIns="0">
+          <a:bodyPr wrap="square" lIns="0" tIns="0" rIns="0" bIns="0">
             <a:spAutoFit/>
           </a:bodyPr>
           <a:lstStyle/>
@@ -6176,6 +6262,7 @@
           <a:lstStyle/>
           <a:p>
             <a:pPr algn="ctr"/>
+            <a:endParaRPr/>
           </a:p>
         </p:txBody>
       </p:sp>
@@ -6196,7 +6283,7 @@
           <a:noFill/>
         </p:spPr>
         <p:txBody>
-          <a:bodyPr wrap="none" lIns="0" rIns="0" tIns="0" bIns="0">
+          <a:bodyPr wrap="none" lIns="0" tIns="0" rIns="0" bIns="0">
             <a:spAutoFit/>
           </a:bodyPr>
           <a:lstStyle/>
@@ -6257,6 +6344,7 @@
           <a:lstStyle/>
           <a:p>
             <a:pPr algn="ctr"/>
+            <a:endParaRPr/>
           </a:p>
         </p:txBody>
       </p:sp>
@@ -6277,7 +6365,7 @@
           <a:noFill/>
         </p:spPr>
         <p:txBody>
-          <a:bodyPr wrap="square" lIns="0" rIns="0" tIns="0" bIns="0">
+          <a:bodyPr wrap="square" lIns="0" tIns="0" rIns="0" bIns="0">
             <a:spAutoFit/>
           </a:bodyPr>
           <a:lstStyle/>
@@ -6386,6 +6474,7 @@
           <a:lstStyle/>
           <a:p>
             <a:pPr algn="ctr"/>
+            <a:endParaRPr/>
           </a:p>
         </p:txBody>
       </p:sp>
@@ -6406,7 +6495,7 @@
           <a:noFill/>
         </p:spPr>
         <p:txBody>
-          <a:bodyPr wrap="square" lIns="0" rIns="0" tIns="0" bIns="0">
+          <a:bodyPr wrap="square" lIns="0" tIns="0" rIns="0" bIns="0">
             <a:spAutoFit/>
           </a:bodyPr>
           <a:lstStyle/>
@@ -6515,6 +6604,7 @@
           <a:lstStyle/>
           <a:p>
             <a:pPr algn="ctr"/>
+            <a:endParaRPr/>
           </a:p>
         </p:txBody>
       </p:sp>
@@ -6535,7 +6625,7 @@
           <a:noFill/>
         </p:spPr>
         <p:txBody>
-          <a:bodyPr wrap="square" lIns="0" rIns="0" tIns="0" bIns="0">
+          <a:bodyPr wrap="square" lIns="0" tIns="0" rIns="0" bIns="0">
             <a:spAutoFit/>
           </a:bodyPr>
           <a:lstStyle/>
@@ -6644,6 +6734,7 @@
           <a:lstStyle/>
           <a:p>
             <a:pPr algn="ctr"/>
+            <a:endParaRPr/>
           </a:p>
         </p:txBody>
       </p:sp>
@@ -6664,7 +6755,7 @@
           <a:noFill/>
         </p:spPr>
         <p:txBody>
-          <a:bodyPr wrap="square" lIns="0" rIns="0" tIns="0" bIns="0">
+          <a:bodyPr wrap="square" lIns="0" tIns="0" rIns="0" bIns="0">
             <a:spAutoFit/>
           </a:bodyPr>
           <a:lstStyle/>
@@ -6740,7 +6831,7 @@
 </file>
 
 <file path=ppt/slides/slide3.xml><?xml version="1.0" encoding="utf-8"?>
-<p:sld xmlns:a="http://schemas.openxmlformats.org/drawingml/2006/main" xmlns:p="http://schemas.openxmlformats.org/presentationml/2006/main" xmlns:r="http://schemas.openxmlformats.org/officeDocument/2006/relationships">
+<p:sld xmlns:a="http://schemas.openxmlformats.org/drawingml/2006/main" xmlns:r="http://schemas.openxmlformats.org/officeDocument/2006/relationships" xmlns:p="http://schemas.openxmlformats.org/presentationml/2006/main">
   <p:cSld>
     <p:spTree>
       <p:nvGrpSpPr>
@@ -6748,7 +6839,14 @@
         <p:cNvGrpSpPr/>
         <p:nvPr/>
       </p:nvGrpSpPr>
-      <p:grpSpPr/>
+      <p:grpSpPr>
+        <a:xfrm>
+          <a:off x="0" y="0"/>
+          <a:ext cx="0" cy="0"/>
+          <a:chOff x="0" y="0"/>
+          <a:chExt cx="0" cy="0"/>
+        </a:xfrm>
+      </p:grpSpPr>
       <p:sp>
         <p:nvSpPr>
           <p:cNvPr id="2" name="Rectangle 1"/>
@@ -6789,6 +6887,7 @@
           <a:lstStyle/>
           <a:p>
             <a:pPr algn="ctr"/>
+            <a:endParaRPr/>
           </a:p>
         </p:txBody>
       </p:sp>
@@ -6809,7 +6908,7 @@
           <a:noFill/>
         </p:spPr>
         <p:txBody>
-          <a:bodyPr wrap="square" lIns="0" rIns="0" tIns="0" bIns="0">
+          <a:bodyPr wrap="square" lIns="0" tIns="0" rIns="0" bIns="0">
             <a:spAutoFit/>
           </a:bodyPr>
           <a:lstStyle/>
@@ -6845,7 +6944,7 @@
           <a:noFill/>
         </p:spPr>
         <p:txBody>
-          <a:bodyPr wrap="square" lIns="0" rIns="0" tIns="0" bIns="0">
+          <a:bodyPr wrap="square" lIns="0" tIns="0" rIns="0" bIns="0">
             <a:spAutoFit/>
           </a:bodyPr>
           <a:lstStyle/>
@@ -6904,6 +7003,7 @@
           <a:lstStyle/>
           <a:p>
             <a:pPr algn="ctr"/>
+            <a:endParaRPr/>
           </a:p>
         </p:txBody>
       </p:sp>
@@ -6924,7 +7024,7 @@
           <a:noFill/>
         </p:spPr>
         <p:txBody>
-          <a:bodyPr wrap="none" lIns="0" rIns="0" tIns="0" bIns="0">
+          <a:bodyPr wrap="none" lIns="0" tIns="0" rIns="0" bIns="0">
             <a:spAutoFit/>
           </a:bodyPr>
           <a:lstStyle/>
@@ -6985,6 +7085,7 @@
           <a:lstStyle/>
           <a:p>
             <a:pPr algn="ctr"/>
+            <a:endParaRPr/>
           </a:p>
         </p:txBody>
       </p:sp>
@@ -7005,7 +7106,7 @@
           <a:noFill/>
         </p:spPr>
         <p:txBody>
-          <a:bodyPr wrap="square" lIns="0" rIns="0" tIns="0" bIns="0">
+          <a:bodyPr wrap="square" lIns="0" tIns="0" rIns="0" bIns="0">
             <a:spAutoFit/>
           </a:bodyPr>
           <a:lstStyle/>
@@ -7114,6 +7215,7 @@
           <a:lstStyle/>
           <a:p>
             <a:pPr algn="ctr"/>
+            <a:endParaRPr/>
           </a:p>
         </p:txBody>
       </p:sp>
@@ -7134,7 +7236,7 @@
           <a:noFill/>
         </p:spPr>
         <p:txBody>
-          <a:bodyPr wrap="square" lIns="0" rIns="0" tIns="0" bIns="0">
+          <a:bodyPr wrap="square" lIns="0" tIns="0" rIns="0" bIns="0">
             <a:spAutoFit/>
           </a:bodyPr>
           <a:lstStyle/>
@@ -7243,6 +7345,7 @@
           <a:lstStyle/>
           <a:p>
             <a:pPr algn="ctr"/>
+            <a:endParaRPr/>
           </a:p>
         </p:txBody>
       </p:sp>
@@ -7263,7 +7366,7 @@
           <a:noFill/>
         </p:spPr>
         <p:txBody>
-          <a:bodyPr wrap="square" lIns="0" rIns="0" tIns="0" bIns="0">
+          <a:bodyPr wrap="square" lIns="0" tIns="0" rIns="0" bIns="0">
             <a:spAutoFit/>
           </a:bodyPr>
           <a:lstStyle/>
@@ -7339,7 +7442,7 @@
 </file>
 
 <file path=ppt/slides/slide4.xml><?xml version="1.0" encoding="utf-8"?>
-<p:sld xmlns:a="http://schemas.openxmlformats.org/drawingml/2006/main" xmlns:p="http://schemas.openxmlformats.org/presentationml/2006/main" xmlns:r="http://schemas.openxmlformats.org/officeDocument/2006/relationships">
+<p:sld xmlns:a="http://schemas.openxmlformats.org/drawingml/2006/main" xmlns:r="http://schemas.openxmlformats.org/officeDocument/2006/relationships" xmlns:p="http://schemas.openxmlformats.org/presentationml/2006/main">
   <p:cSld>
     <p:spTree>
       <p:nvGrpSpPr>
@@ -7347,7 +7450,14 @@
         <p:cNvGrpSpPr/>
         <p:nvPr/>
       </p:nvGrpSpPr>
-      <p:grpSpPr/>
+      <p:grpSpPr>
+        <a:xfrm>
+          <a:off x="0" y="0"/>
+          <a:ext cx="0" cy="0"/>
+          <a:chOff x="0" y="0"/>
+          <a:chExt cx="0" cy="0"/>
+        </a:xfrm>
+      </p:grpSpPr>
       <p:sp>
         <p:nvSpPr>
           <p:cNvPr id="2" name="Rectangle 1"/>
@@ -7388,6 +7498,7 @@
           <a:lstStyle/>
           <a:p>
             <a:pPr algn="ctr"/>
+            <a:endParaRPr/>
           </a:p>
         </p:txBody>
       </p:sp>
@@ -7408,7 +7519,7 @@
           <a:noFill/>
         </p:spPr>
         <p:txBody>
-          <a:bodyPr wrap="square" lIns="0" rIns="0" tIns="0" bIns="0">
+          <a:bodyPr wrap="square" lIns="0" tIns="0" rIns="0" bIns="0">
             <a:spAutoFit/>
           </a:bodyPr>
           <a:lstStyle/>
@@ -7444,7 +7555,7 @@
           <a:noFill/>
         </p:spPr>
         <p:txBody>
-          <a:bodyPr wrap="square" lIns="0" rIns="0" tIns="0" bIns="0">
+          <a:bodyPr wrap="square" lIns="0" tIns="0" rIns="0" bIns="0">
             <a:spAutoFit/>
           </a:bodyPr>
           <a:lstStyle/>
@@ -7458,7 +7569,7 @@
               </a:defRPr>
             </a:pPr>
             <a:r>
-              <a:t>Enterprise Technical Architecture &amp; Reliability</a:t>
+              <a:t>Enterprise Technical Architecture &amp; System Topology</a:t>
             </a:r>
           </a:p>
         </p:txBody>
@@ -7503,6 +7614,7 @@
           <a:lstStyle/>
           <a:p>
             <a:pPr algn="ctr"/>
+            <a:endParaRPr/>
           </a:p>
         </p:txBody>
       </p:sp>
@@ -7523,7 +7635,7 @@
           <a:noFill/>
         </p:spPr>
         <p:txBody>
-          <a:bodyPr wrap="none" lIns="0" rIns="0" tIns="0" bIns="0">
+          <a:bodyPr wrap="none" lIns="0" tIns="0" rIns="0" bIns="0">
             <a:spAutoFit/>
           </a:bodyPr>
           <a:lstStyle/>
@@ -7551,7 +7663,7 @@
         <p:spPr>
           <a:xfrm>
             <a:off x="731520" y="1463040"/>
-            <a:ext cx="6217920" cy="1371600"/>
+            <a:ext cx="4846320" cy="1371600"/>
           </a:xfrm>
           <a:prstGeom prst="roundRect">
             <a:avLst/>
@@ -7584,6 +7696,7 @@
           <a:lstStyle/>
           <a:p>
             <a:pPr algn="ctr"/>
+            <a:endParaRPr/>
           </a:p>
         </p:txBody>
       </p:sp>
@@ -7596,7 +7709,7 @@
         <p:spPr>
           <a:xfrm>
             <a:off x="960120" y="1645920"/>
-            <a:ext cx="5760720" cy="1005840"/>
+            <a:ext cx="4389120" cy="1005840"/>
           </a:xfrm>
           <a:prstGeom prst="rect">
             <a:avLst/>
@@ -7604,7 +7717,7 @@
           <a:noFill/>
         </p:spPr>
         <p:txBody>
-          <a:bodyPr wrap="square" lIns="0" rIns="0" tIns="0" bIns="0">
+          <a:bodyPr wrap="square" lIns="0" tIns="0" rIns="0" bIns="0">
             <a:spAutoFit/>
           </a:bodyPr>
           <a:lstStyle/>
@@ -7618,7 +7731,7 @@
               </a:defRPr>
             </a:pPr>
             <a:r>
-              <a:t>Frontend Layer (Next.js 16 + React 19 + Turbopack)</a:t>
+              <a:t>Presentation Layer (Next.js 16 + React 19 + Turbopack)</a:t>
             </a:r>
           </a:p>
           <a:p>
@@ -7634,7 +7747,7 @@
               </a:defRPr>
             </a:pPr>
             <a:r>
-              <a:t>• Zero-latency optimistic UI with localized multi-language i18n (EN, HI, GU).</a:t>
+              <a:t>• Optimistic UI with multilingual i18n (EN, HI, GU).</a:t>
             </a:r>
           </a:p>
           <a:p>
@@ -7650,7 +7763,7 @@
               </a:defRPr>
             </a:pPr>
             <a:r>
-              <a:t>• PWA shell with Web Push notification service worker and mobile design.</a:t>
+              <a:t>• PWA shell with Web Push and audio chime triggers.</a:t>
             </a:r>
           </a:p>
         </p:txBody>
@@ -7664,7 +7777,7 @@
         <p:spPr>
           <a:xfrm>
             <a:off x="731520" y="2971800"/>
-            <a:ext cx="6217920" cy="1371600"/>
+            <a:ext cx="4846320" cy="1371600"/>
           </a:xfrm>
           <a:prstGeom prst="roundRect">
             <a:avLst/>
@@ -7697,6 +7810,7 @@
           <a:lstStyle/>
           <a:p>
             <a:pPr algn="ctr"/>
+            <a:endParaRPr/>
           </a:p>
         </p:txBody>
       </p:sp>
@@ -7709,7 +7823,7 @@
         <p:spPr>
           <a:xfrm>
             <a:off x="960120" y="3154680"/>
-            <a:ext cx="5760720" cy="1005840"/>
+            <a:ext cx="4389120" cy="1005840"/>
           </a:xfrm>
           <a:prstGeom prst="rect">
             <a:avLst/>
@@ -7717,7 +7831,7 @@
           <a:noFill/>
         </p:spPr>
         <p:txBody>
-          <a:bodyPr wrap="square" lIns="0" rIns="0" tIns="0" bIns="0">
+          <a:bodyPr wrap="square" lIns="0" tIns="0" rIns="0" bIns="0">
             <a:spAutoFit/>
           </a:bodyPr>
           <a:lstStyle/>
@@ -7731,7 +7845,7 @@
               </a:defRPr>
             </a:pPr>
             <a:r>
-              <a:t>Backend Services (FastAPI + Python 3.12 Asynchronous Core)</a:t>
+              <a:t>API &amp; Gateway (FastAPI + Starlette WebSockets)</a:t>
             </a:r>
           </a:p>
           <a:p>
@@ -7747,7 +7861,7 @@
               </a:defRPr>
             </a:pPr>
             <a:r>
-              <a:t>• Stateless JWT authentication with rotating tokens &amp; RBAC security decorators.</a:t>
+              <a:t>• Stateless JWT auth with role-based security guards.</a:t>
             </a:r>
           </a:p>
           <a:p>
@@ -7763,7 +7877,7 @@
               </a:defRPr>
             </a:pPr>
             <a:r>
-              <a:t>• High-throughput REST API endpoints with Pydantic payload validation.</a:t>
+              <a:t>• Sub-second real-time event broadcasting mesh.</a:t>
             </a:r>
           </a:p>
         </p:txBody>
@@ -7777,7 +7891,7 @@
         <p:spPr>
           <a:xfrm>
             <a:off x="731520" y="4480560"/>
-            <a:ext cx="6217920" cy="1371600"/>
+            <a:ext cx="4846320" cy="1371600"/>
           </a:xfrm>
           <a:prstGeom prst="roundRect">
             <a:avLst/>
@@ -7810,6 +7924,7 @@
           <a:lstStyle/>
           <a:p>
             <a:pPr algn="ctr"/>
+            <a:endParaRPr/>
           </a:p>
         </p:txBody>
       </p:sp>
@@ -7822,7 +7937,7 @@
         <p:spPr>
           <a:xfrm>
             <a:off x="960120" y="4663440"/>
-            <a:ext cx="5760720" cy="1005840"/>
+            <a:ext cx="4389120" cy="1005840"/>
           </a:xfrm>
           <a:prstGeom prst="rect">
             <a:avLst/>
@@ -7830,7 +7945,7 @@
           <a:noFill/>
         </p:spPr>
         <p:txBody>
-          <a:bodyPr wrap="square" lIns="0" rIns="0" tIns="0" bIns="0">
+          <a:bodyPr wrap="square" lIns="0" tIns="0" rIns="0" bIns="0">
             <a:spAutoFit/>
           </a:bodyPr>
           <a:lstStyle/>
@@ -7844,7 +7959,7 @@
               </a:defRPr>
             </a:pPr>
             <a:r>
-              <a:t>Database &amp; Persistence (PostgreSQL / SQLite + SQLAlchemy 2.0)</a:t>
+              <a:t>Data Core (PostgreSQL / SQLite + SQLAlchemy 2.0)</a:t>
             </a:r>
           </a:p>
           <a:p>
@@ -7860,7 +7975,7 @@
               </a:defRPr>
             </a:pPr>
             <a:r>
-              <a:t>• Relational data model with cascading integrity constraints &amp; connection pooling.</a:t>
+              <a:t>• Cascading integrity protection &amp; immutable audit logs.</a:t>
             </a:r>
           </a:p>
           <a:p>
@@ -7876,7 +7991,7 @@
               </a:defRPr>
             </a:pPr>
             <a:r>
-              <a:t>• Immutable audit logs, real-time WebSocket broadcaster, and automated seeders.</a:t>
+              <a:t>• Encrypted browser storage fallback with tombstone keys.</a:t>
             </a:r>
           </a:p>
         </p:txBody>
@@ -7889,8 +8004,8 @@
         </p:nvSpPr>
         <p:spPr>
           <a:xfrm>
-            <a:off x="7132320" y="1463040"/>
-            <a:ext cx="4327855" cy="4480560"/>
+            <a:off x="5724144" y="1426464"/>
+            <a:ext cx="5772607" cy="4553712"/>
           </a:xfrm>
           <a:prstGeom prst="roundRect">
             <a:avLst/>
@@ -7923,19 +8038,44 @@
           <a:lstStyle/>
           <a:p>
             <a:pPr algn="ctr"/>
-          </a:p>
-        </p:txBody>
-      </p:sp>
-      <p:sp>
-        <p:nvSpPr>
-          <p:cNvPr id="14" name="TextBox 13"/>
+            <a:endParaRPr/>
+          </a:p>
+        </p:txBody>
+      </p:sp>
+      <p:pic>
+        <p:nvPicPr>
+          <p:cNvPr id="14" name="Picture 13" descr="architecture_diagram.png"/>
+          <p:cNvPicPr>
+            <a:picLocks noChangeAspect="1"/>
+          </p:cNvPicPr>
+          <p:nvPr/>
+        </p:nvPicPr>
+        <p:blipFill>
+          <a:blip r:embed="rId2"/>
+          <a:stretch>
+            <a:fillRect/>
+          </a:stretch>
+        </p:blipFill>
+        <p:spPr>
+          <a:xfrm>
+            <a:off x="5577840" y="1289304"/>
+            <a:ext cx="6141454" cy="4828032"/>
+          </a:xfrm>
+          <a:prstGeom prst="rect">
+            <a:avLst/>
+          </a:prstGeom>
+        </p:spPr>
+      </p:pic>
+      <p:sp>
+        <p:nvSpPr>
+          <p:cNvPr id="15" name="TextBox 14"/>
           <p:cNvSpPr txBox="1"/>
           <p:nvPr/>
         </p:nvSpPr>
         <p:spPr>
           <a:xfrm>
-            <a:off x="7315200" y="3154680"/>
-            <a:ext cx="3962095" cy="1097280"/>
+            <a:off x="5760720" y="6016752"/>
+            <a:ext cx="5699455" cy="274320"/>
           </a:xfrm>
           <a:prstGeom prst="rect">
             <a:avLst/>
@@ -7943,13 +8083,13 @@
           <a:noFill/>
         </p:spPr>
         <p:txBody>
-          <a:bodyPr wrap="square" lIns="0" rIns="0" tIns="0" bIns="0">
+          <a:bodyPr wrap="none" lIns="0" tIns="0" rIns="0" bIns="0">
             <a:spAutoFit/>
           </a:bodyPr>
           <a:lstStyle/>
           <a:p>
             <a:pPr algn="ctr">
-              <a:defRPr sz="1200" b="1">
+              <a:defRPr sz="950" b="1">
                 <a:solidFill>
                   <a:srgbClr val="60A5FA"/>
                 </a:solidFill>
@@ -7957,33 +8097,7 @@
               </a:defRPr>
             </a:pPr>
             <a:r>
-              <a:t>📸 Architecture &amp; Data Flow Diagram</a:t>
-            </a:r>
-          </a:p>
-          <a:p>
-            <a:pPr algn="ctr">
-              <a:defRPr sz="950">
-                <a:solidFill>
-                  <a:srgbClr val="94A3B8"/>
-                </a:solidFill>
-                <a:latin typeface="Arial"/>
-              </a:defRPr>
-            </a:pPr>
-            <a:r>
-              <a:t>Insert System Architecture Diagram Here</a:t>
-            </a:r>
-          </a:p>
-          <a:p>
-            <a:pPr algn="ctr">
-              <a:defRPr sz="850" i="1">
-                <a:solidFill>
-                  <a:srgbClr val="94A3B8"/>
-                </a:solidFill>
-                <a:latin typeface="Arial"/>
-              </a:defRPr>
-            </a:pPr>
-            <a:r>
-              <a:t>(Right Click → Change Picture / Paste Screenshot)</a:t>
+              <a:t>📸 System Architecture &amp; Data Gateway</a:t>
             </a:r>
           </a:p>
         </p:txBody>
@@ -7997,7 +8111,7 @@
 </file>
 
 <file path=ppt/slides/slide5.xml><?xml version="1.0" encoding="utf-8"?>
-<p:sld xmlns:a="http://schemas.openxmlformats.org/drawingml/2006/main" xmlns:p="http://schemas.openxmlformats.org/presentationml/2006/main" xmlns:r="http://schemas.openxmlformats.org/officeDocument/2006/relationships">
+<p:sld xmlns:a="http://schemas.openxmlformats.org/drawingml/2006/main" xmlns:r="http://schemas.openxmlformats.org/officeDocument/2006/relationships" xmlns:p="http://schemas.openxmlformats.org/presentationml/2006/main">
   <p:cSld>
     <p:spTree>
       <p:nvGrpSpPr>
@@ -8005,7 +8119,14 @@
         <p:cNvGrpSpPr/>
         <p:nvPr/>
       </p:nvGrpSpPr>
-      <p:grpSpPr/>
+      <p:grpSpPr>
+        <a:xfrm>
+          <a:off x="0" y="0"/>
+          <a:ext cx="0" cy="0"/>
+          <a:chOff x="0" y="0"/>
+          <a:chExt cx="0" cy="0"/>
+        </a:xfrm>
+      </p:grpSpPr>
       <p:sp>
         <p:nvSpPr>
           <p:cNvPr id="2" name="Rectangle 1"/>
@@ -8046,6 +8167,7 @@
           <a:lstStyle/>
           <a:p>
             <a:pPr algn="ctr"/>
+            <a:endParaRPr/>
           </a:p>
         </p:txBody>
       </p:sp>
@@ -8066,7 +8188,7 @@
           <a:noFill/>
         </p:spPr>
         <p:txBody>
-          <a:bodyPr wrap="square" lIns="0" rIns="0" tIns="0" bIns="0">
+          <a:bodyPr wrap="square" lIns="0" tIns="0" rIns="0" bIns="0">
             <a:spAutoFit/>
           </a:bodyPr>
           <a:lstStyle/>
@@ -8102,7 +8224,7 @@
           <a:noFill/>
         </p:spPr>
         <p:txBody>
-          <a:bodyPr wrap="square" lIns="0" rIns="0" tIns="0" bIns="0">
+          <a:bodyPr wrap="square" lIns="0" tIns="0" rIns="0" bIns="0">
             <a:spAutoFit/>
           </a:bodyPr>
           <a:lstStyle/>
@@ -8116,7 +8238,7 @@
               </a:defRPr>
             </a:pPr>
             <a:r>
-              <a:t>End-to-End Procurement &amp; Approval Workflow</a:t>
+              <a:t>End-to-End Requisition Pipeline &amp; Approval Lifecycle</a:t>
             </a:r>
           </a:p>
         </p:txBody>
@@ -8161,6 +8283,7 @@
           <a:lstStyle/>
           <a:p>
             <a:pPr algn="ctr"/>
+            <a:endParaRPr/>
           </a:p>
         </p:txBody>
       </p:sp>
@@ -8181,7 +8304,7 @@
           <a:noFill/>
         </p:spPr>
         <p:txBody>
-          <a:bodyPr wrap="none" lIns="0" rIns="0" tIns="0" bIns="0">
+          <a:bodyPr wrap="none" lIns="0" tIns="0" rIns="0" bIns="0">
             <a:spAutoFit/>
           </a:bodyPr>
           <a:lstStyle/>
@@ -8208,18 +8331,18 @@
         </p:nvSpPr>
         <p:spPr>
           <a:xfrm>
-            <a:off x="731520" y="1463040"/>
-            <a:ext cx="2057400" cy="4572000"/>
+            <a:off x="694944" y="1380744"/>
+            <a:ext cx="10801807" cy="4736592"/>
           </a:xfrm>
           <a:prstGeom prst="roundRect">
             <a:avLst/>
           </a:prstGeom>
           <a:solidFill>
-            <a:srgbClr val="1E293B"/>
+            <a:srgbClr val="182235"/>
           </a:solidFill>
-          <a:ln>
+          <a:ln w="19050">
             <a:solidFill>
-              <a:srgbClr val="334155"/>
+              <a:srgbClr val="60A5FA"/>
             </a:solidFill>
           </a:ln>
         </p:spPr>
@@ -8242,61 +8365,34 @@
           <a:lstStyle/>
           <a:p>
             <a:pPr algn="ctr"/>
-          </a:p>
-        </p:txBody>
-      </p:sp>
-      <p:sp>
-        <p:nvSpPr>
-          <p:cNvPr id="8" name="Rounded Rectangle 7"/>
-          <p:cNvSpPr/>
-          <p:nvPr/>
-        </p:nvSpPr>
-        <p:spPr>
-          <a:xfrm>
-            <a:off x="868680" y="1645920"/>
-            <a:ext cx="1783080" cy="411480"/>
-          </a:xfrm>
-          <a:prstGeom prst="roundRect">
-            <a:avLst/>
-          </a:prstGeom>
-          <a:solidFill>
-            <a:srgbClr val="3B82F6"/>
-          </a:solidFill>
-          <a:ln>
-            <a:noFill/>
-          </a:ln>
-        </p:spPr>
-        <p:style>
-          <a:lnRef idx="1">
-            <a:schemeClr val="accent1"/>
-          </a:lnRef>
-          <a:fillRef idx="3">
-            <a:schemeClr val="accent1"/>
-          </a:fillRef>
-          <a:effectRef idx="2">
-            <a:schemeClr val="accent1"/>
-          </a:effectRef>
-          <a:fontRef idx="minor">
-            <a:schemeClr val="lt1"/>
-          </a:fontRef>
-        </p:style>
-        <p:txBody>
-          <a:bodyPr rtlCol="0" anchor="ctr"/>
-          <a:lstStyle/>
-          <a:p>
-            <a:pPr algn="ctr">
-              <a:defRPr sz="1000" b="1">
-                <a:solidFill>
-                  <a:srgbClr val="FFFFFF"/>
-                </a:solidFill>
-              </a:defRPr>
-            </a:pPr>
-            <a:r>
-              <a:t>STEP 1</a:t>
-            </a:r>
-          </a:p>
-        </p:txBody>
-      </p:sp>
+            <a:endParaRPr/>
+          </a:p>
+        </p:txBody>
+      </p:sp>
+      <p:pic>
+        <p:nvPicPr>
+          <p:cNvPr id="8" name="Picture 7" descr="order_flow_diagram.png"/>
+          <p:cNvPicPr>
+            <a:picLocks noChangeAspect="1"/>
+          </p:cNvPicPr>
+          <p:nvPr/>
+        </p:nvPicPr>
+        <p:blipFill>
+          <a:blip r:embed="rId2"/>
+          <a:stretch>
+            <a:fillRect/>
+          </a:stretch>
+        </p:blipFill>
+        <p:spPr>
+          <a:xfrm>
+            <a:off x="731520" y="1417320"/>
+            <a:ext cx="10728655" cy="4663440"/>
+          </a:xfrm>
+          <a:prstGeom prst="rect">
+            <a:avLst/>
+          </a:prstGeom>
+        </p:spPr>
+      </p:pic>
       <p:sp>
         <p:nvSpPr>
           <p:cNvPr id="9" name="TextBox 8"/>
@@ -8305,8 +8401,8 @@
         </p:nvSpPr>
         <p:spPr>
           <a:xfrm>
-            <a:off x="868680" y="2194560"/>
-            <a:ext cx="1783080" cy="3657600"/>
+            <a:off x="731520" y="6153912"/>
+            <a:ext cx="10728655" cy="274320"/>
           </a:xfrm>
           <a:prstGeom prst="rect">
             <a:avLst/>
@@ -8314,795 +8410,21 @@
           <a:noFill/>
         </p:spPr>
         <p:txBody>
-          <a:bodyPr wrap="square">
+          <a:bodyPr wrap="none" lIns="0" tIns="0" rIns="0" bIns="0">
             <a:spAutoFit/>
           </a:bodyPr>
           <a:lstStyle/>
           <a:p>
-            <a:pPr>
-              <a:defRPr sz="1200" b="1">
-                <a:solidFill>
-                  <a:srgbClr val="F8FAFC"/>
-                </a:solidFill>
-              </a:defRPr>
-            </a:pPr>
-            <a:r>
-              <a:t>1. Coordinator</a:t>
-            </a:r>
-          </a:p>
-          <a:p>
-            <a:pPr>
-              <a:spcBef>
-                <a:spcPts val="800"/>
-              </a:spcBef>
-              <a:defRPr sz="950">
-                <a:solidFill>
-                  <a:srgbClr val="94A3B8"/>
-                </a:solidFill>
-              </a:defRPr>
-            </a:pPr>
-            <a:r>
-              <a:t>Drafts requisitions, selects live menu items, submits to Principal.</a:t>
-            </a:r>
-          </a:p>
-        </p:txBody>
-      </p:sp>
-      <p:sp>
-        <p:nvSpPr>
-          <p:cNvPr id="10" name="Right Arrow 9"/>
-          <p:cNvSpPr/>
-          <p:nvPr/>
-        </p:nvSpPr>
-        <p:spPr>
-          <a:xfrm>
-            <a:off x="2816351" y="3566160"/>
-            <a:ext cx="146304" cy="219456"/>
-          </a:xfrm>
-          <a:prstGeom prst="rightArrow">
-            <a:avLst/>
-          </a:prstGeom>
-          <a:solidFill>
-            <a:srgbClr val="60A5FA"/>
-          </a:solidFill>
-          <a:ln>
-            <a:noFill/>
-          </a:ln>
-        </p:spPr>
-        <p:style>
-          <a:lnRef idx="1">
-            <a:schemeClr val="accent1"/>
-          </a:lnRef>
-          <a:fillRef idx="3">
-            <a:schemeClr val="accent1"/>
-          </a:fillRef>
-          <a:effectRef idx="2">
-            <a:schemeClr val="accent1"/>
-          </a:effectRef>
-          <a:fontRef idx="minor">
-            <a:schemeClr val="lt1"/>
-          </a:fontRef>
-        </p:style>
-        <p:txBody>
-          <a:bodyPr rtlCol="0" anchor="ctr"/>
-          <a:lstStyle/>
-          <a:p>
-            <a:pPr algn="ctr"/>
-          </a:p>
-        </p:txBody>
-      </p:sp>
-      <p:sp>
-        <p:nvSpPr>
-          <p:cNvPr id="11" name="Rounded Rectangle 10"/>
-          <p:cNvSpPr/>
-          <p:nvPr/>
-        </p:nvSpPr>
-        <p:spPr>
-          <a:xfrm>
-            <a:off x="2907791" y="1463040"/>
-            <a:ext cx="2057400" cy="4572000"/>
-          </a:xfrm>
-          <a:prstGeom prst="roundRect">
-            <a:avLst/>
-          </a:prstGeom>
-          <a:solidFill>
-            <a:srgbClr val="1E293B"/>
-          </a:solidFill>
-          <a:ln>
-            <a:solidFill>
-              <a:srgbClr val="334155"/>
-            </a:solidFill>
-          </a:ln>
-        </p:spPr>
-        <p:style>
-          <a:lnRef idx="1">
-            <a:schemeClr val="accent1"/>
-          </a:lnRef>
-          <a:fillRef idx="3">
-            <a:schemeClr val="accent1"/>
-          </a:fillRef>
-          <a:effectRef idx="2">
-            <a:schemeClr val="accent1"/>
-          </a:effectRef>
-          <a:fontRef idx="minor">
-            <a:schemeClr val="lt1"/>
-          </a:fontRef>
-        </p:style>
-        <p:txBody>
-          <a:bodyPr rtlCol="0" anchor="ctr"/>
-          <a:lstStyle/>
-          <a:p>
-            <a:pPr algn="ctr"/>
-          </a:p>
-        </p:txBody>
-      </p:sp>
-      <p:sp>
-        <p:nvSpPr>
-          <p:cNvPr id="12" name="Rounded Rectangle 11"/>
-          <p:cNvSpPr/>
-          <p:nvPr/>
-        </p:nvSpPr>
-        <p:spPr>
-          <a:xfrm>
-            <a:off x="3044951" y="1645920"/>
-            <a:ext cx="1783080" cy="411480"/>
-          </a:xfrm>
-          <a:prstGeom prst="roundRect">
-            <a:avLst/>
-          </a:prstGeom>
-          <a:solidFill>
-            <a:srgbClr val="06B6D4"/>
-          </a:solidFill>
-          <a:ln>
-            <a:noFill/>
-          </a:ln>
-        </p:spPr>
-        <p:style>
-          <a:lnRef idx="1">
-            <a:schemeClr val="accent1"/>
-          </a:lnRef>
-          <a:fillRef idx="3">
-            <a:schemeClr val="accent1"/>
-          </a:fillRef>
-          <a:effectRef idx="2">
-            <a:schemeClr val="accent1"/>
-          </a:effectRef>
-          <a:fontRef idx="minor">
-            <a:schemeClr val="lt1"/>
-          </a:fontRef>
-        </p:style>
-        <p:txBody>
-          <a:bodyPr rtlCol="0" anchor="ctr"/>
-          <a:lstStyle/>
-          <a:p>
             <a:pPr algn="ctr">
-              <a:defRPr sz="1000" b="1">
-                <a:solidFill>
-                  <a:srgbClr val="FFFFFF"/>
-                </a:solidFill>
-              </a:defRPr>
-            </a:pPr>
-            <a:r>
-              <a:t>STEP 2</a:t>
-            </a:r>
-          </a:p>
-        </p:txBody>
-      </p:sp>
-      <p:sp>
-        <p:nvSpPr>
-          <p:cNvPr id="13" name="TextBox 12"/>
-          <p:cNvSpPr txBox="1"/>
-          <p:nvPr/>
-        </p:nvSpPr>
-        <p:spPr>
-          <a:xfrm>
-            <a:off x="3044951" y="2194560"/>
-            <a:ext cx="1783080" cy="3657600"/>
-          </a:xfrm>
-          <a:prstGeom prst="rect">
-            <a:avLst/>
-          </a:prstGeom>
-          <a:noFill/>
-        </p:spPr>
-        <p:txBody>
-          <a:bodyPr wrap="square">
-            <a:spAutoFit/>
-          </a:bodyPr>
-          <a:lstStyle/>
-          <a:p>
-            <a:pPr>
-              <a:defRPr sz="1200" b="1">
-                <a:solidFill>
-                  <a:srgbClr val="F8FAFC"/>
-                </a:solidFill>
-              </a:defRPr>
-            </a:pPr>
-            <a:r>
-              <a:t>2. Principal</a:t>
-            </a:r>
-          </a:p>
-          <a:p>
-            <a:pPr>
-              <a:spcBef>
-                <a:spcPts val="800"/>
-              </a:spcBef>
-              <a:defRPr sz="950">
-                <a:solidFill>
-                  <a:srgbClr val="94A3B8"/>
-                </a:solidFill>
-              </a:defRPr>
-            </a:pPr>
-            <a:r>
-              <a:t>Reviews departmental budget, approves or rejects with official remarks.</a:t>
-            </a:r>
-          </a:p>
-        </p:txBody>
-      </p:sp>
-      <p:sp>
-        <p:nvSpPr>
-          <p:cNvPr id="14" name="Right Arrow 13"/>
-          <p:cNvSpPr/>
-          <p:nvPr/>
-        </p:nvSpPr>
-        <p:spPr>
-          <a:xfrm>
-            <a:off x="4992622" y="3566160"/>
-            <a:ext cx="146304" cy="219456"/>
-          </a:xfrm>
-          <a:prstGeom prst="rightArrow">
-            <a:avLst/>
-          </a:prstGeom>
-          <a:solidFill>
-            <a:srgbClr val="60A5FA"/>
-          </a:solidFill>
-          <a:ln>
-            <a:noFill/>
-          </a:ln>
-        </p:spPr>
-        <p:style>
-          <a:lnRef idx="1">
-            <a:schemeClr val="accent1"/>
-          </a:lnRef>
-          <a:fillRef idx="3">
-            <a:schemeClr val="accent1"/>
-          </a:fillRef>
-          <a:effectRef idx="2">
-            <a:schemeClr val="accent1"/>
-          </a:effectRef>
-          <a:fontRef idx="minor">
-            <a:schemeClr val="lt1"/>
-          </a:fontRef>
-        </p:style>
-        <p:txBody>
-          <a:bodyPr rtlCol="0" anchor="ctr"/>
-          <a:lstStyle/>
-          <a:p>
-            <a:pPr algn="ctr"/>
-          </a:p>
-        </p:txBody>
-      </p:sp>
-      <p:sp>
-        <p:nvSpPr>
-          <p:cNvPr id="15" name="Rounded Rectangle 14"/>
-          <p:cNvSpPr/>
-          <p:nvPr/>
-        </p:nvSpPr>
-        <p:spPr>
-          <a:xfrm>
-            <a:off x="5084064" y="1463040"/>
-            <a:ext cx="2057400" cy="4572000"/>
-          </a:xfrm>
-          <a:prstGeom prst="roundRect">
-            <a:avLst/>
-          </a:prstGeom>
-          <a:solidFill>
-            <a:srgbClr val="1E293B"/>
-          </a:solidFill>
-          <a:ln>
-            <a:solidFill>
-              <a:srgbClr val="334155"/>
-            </a:solidFill>
-          </a:ln>
-        </p:spPr>
-        <p:style>
-          <a:lnRef idx="1">
-            <a:schemeClr val="accent1"/>
-          </a:lnRef>
-          <a:fillRef idx="3">
-            <a:schemeClr val="accent1"/>
-          </a:fillRef>
-          <a:effectRef idx="2">
-            <a:schemeClr val="accent1"/>
-          </a:effectRef>
-          <a:fontRef idx="minor">
-            <a:schemeClr val="lt1"/>
-          </a:fontRef>
-        </p:style>
-        <p:txBody>
-          <a:bodyPr rtlCol="0" anchor="ctr"/>
-          <a:lstStyle/>
-          <a:p>
-            <a:pPr algn="ctr"/>
-          </a:p>
-        </p:txBody>
-      </p:sp>
-      <p:sp>
-        <p:nvSpPr>
-          <p:cNvPr id="16" name="Rounded Rectangle 15"/>
-          <p:cNvSpPr/>
-          <p:nvPr/>
-        </p:nvSpPr>
-        <p:spPr>
-          <a:xfrm>
-            <a:off x="5221224" y="1645920"/>
-            <a:ext cx="1783080" cy="411480"/>
-          </a:xfrm>
-          <a:prstGeom prst="roundRect">
-            <a:avLst/>
-          </a:prstGeom>
-          <a:solidFill>
-            <a:srgbClr val="A855F7"/>
-          </a:solidFill>
-          <a:ln>
-            <a:noFill/>
-          </a:ln>
-        </p:spPr>
-        <p:style>
-          <a:lnRef idx="1">
-            <a:schemeClr val="accent1"/>
-          </a:lnRef>
-          <a:fillRef idx="3">
-            <a:schemeClr val="accent1"/>
-          </a:fillRef>
-          <a:effectRef idx="2">
-            <a:schemeClr val="accent1"/>
-          </a:effectRef>
-          <a:fontRef idx="minor">
-            <a:schemeClr val="lt1"/>
-          </a:fontRef>
-        </p:style>
-        <p:txBody>
-          <a:bodyPr rtlCol="0" anchor="ctr"/>
-          <a:lstStyle/>
-          <a:p>
-            <a:pPr algn="ctr">
-              <a:defRPr sz="1000" b="1">
-                <a:solidFill>
-                  <a:srgbClr val="FFFFFF"/>
-                </a:solidFill>
-              </a:defRPr>
-            </a:pPr>
-            <a:r>
-              <a:t>STEP 3</a:t>
-            </a:r>
-          </a:p>
-        </p:txBody>
-      </p:sp>
-      <p:sp>
-        <p:nvSpPr>
-          <p:cNvPr id="17" name="TextBox 16"/>
-          <p:cNvSpPr txBox="1"/>
-          <p:nvPr/>
-        </p:nvSpPr>
-        <p:spPr>
-          <a:xfrm>
-            <a:off x="5221224" y="2194560"/>
-            <a:ext cx="1783080" cy="3657600"/>
-          </a:xfrm>
-          <a:prstGeom prst="rect">
-            <a:avLst/>
-          </a:prstGeom>
-          <a:noFill/>
-        </p:spPr>
-        <p:txBody>
-          <a:bodyPr wrap="square">
-            <a:spAutoFit/>
-          </a:bodyPr>
-          <a:lstStyle/>
-          <a:p>
-            <a:pPr>
-              <a:defRPr sz="1200" b="1">
-                <a:solidFill>
-                  <a:srgbClr val="F8FAFC"/>
-                </a:solidFill>
-              </a:defRPr>
-            </a:pPr>
-            <a:r>
-              <a:t>3. DCR (Discretionary)</a:t>
-            </a:r>
-          </a:p>
-          <a:p>
-            <a:pPr>
-              <a:spcBef>
-                <a:spcPts val="800"/>
-              </a:spcBef>
-              <a:defRPr sz="950">
-                <a:solidFill>
-                  <a:srgbClr val="94A3B8"/>
-                </a:solidFill>
-              </a:defRPr>
-            </a:pPr>
-            <a:r>
-              <a:t>Verifies institutional expense limits and forwards to canteen vendors.</a:t>
-            </a:r>
-          </a:p>
-        </p:txBody>
-      </p:sp>
-      <p:sp>
-        <p:nvSpPr>
-          <p:cNvPr id="18" name="Right Arrow 17"/>
-          <p:cNvSpPr/>
-          <p:nvPr/>
-        </p:nvSpPr>
-        <p:spPr>
-          <a:xfrm>
-            <a:off x="7168895" y="3566160"/>
-            <a:ext cx="146304" cy="219456"/>
-          </a:xfrm>
-          <a:prstGeom prst="rightArrow">
-            <a:avLst/>
-          </a:prstGeom>
-          <a:solidFill>
-            <a:srgbClr val="60A5FA"/>
-          </a:solidFill>
-          <a:ln>
-            <a:noFill/>
-          </a:ln>
-        </p:spPr>
-        <p:style>
-          <a:lnRef idx="1">
-            <a:schemeClr val="accent1"/>
-          </a:lnRef>
-          <a:fillRef idx="3">
-            <a:schemeClr val="accent1"/>
-          </a:fillRef>
-          <a:effectRef idx="2">
-            <a:schemeClr val="accent1"/>
-          </a:effectRef>
-          <a:fontRef idx="minor">
-            <a:schemeClr val="lt1"/>
-          </a:fontRef>
-        </p:style>
-        <p:txBody>
-          <a:bodyPr rtlCol="0" anchor="ctr"/>
-          <a:lstStyle/>
-          <a:p>
-            <a:pPr algn="ctr"/>
-          </a:p>
-        </p:txBody>
-      </p:sp>
-      <p:sp>
-        <p:nvSpPr>
-          <p:cNvPr id="19" name="Rounded Rectangle 18"/>
-          <p:cNvSpPr/>
-          <p:nvPr/>
-        </p:nvSpPr>
-        <p:spPr>
-          <a:xfrm>
-            <a:off x="7260336" y="1463040"/>
-            <a:ext cx="2057400" cy="4572000"/>
-          </a:xfrm>
-          <a:prstGeom prst="roundRect">
-            <a:avLst/>
-          </a:prstGeom>
-          <a:solidFill>
-            <a:srgbClr val="1E293B"/>
-          </a:solidFill>
-          <a:ln>
-            <a:solidFill>
-              <a:srgbClr val="334155"/>
-            </a:solidFill>
-          </a:ln>
-        </p:spPr>
-        <p:style>
-          <a:lnRef idx="1">
-            <a:schemeClr val="accent1"/>
-          </a:lnRef>
-          <a:fillRef idx="3">
-            <a:schemeClr val="accent1"/>
-          </a:fillRef>
-          <a:effectRef idx="2">
-            <a:schemeClr val="accent1"/>
-          </a:effectRef>
-          <a:fontRef idx="minor">
-            <a:schemeClr val="lt1"/>
-          </a:fontRef>
-        </p:style>
-        <p:txBody>
-          <a:bodyPr rtlCol="0" anchor="ctr"/>
-          <a:lstStyle/>
-          <a:p>
-            <a:pPr algn="ctr"/>
-          </a:p>
-        </p:txBody>
-      </p:sp>
-      <p:sp>
-        <p:nvSpPr>
-          <p:cNvPr id="20" name="Rounded Rectangle 19"/>
-          <p:cNvSpPr/>
-          <p:nvPr/>
-        </p:nvSpPr>
-        <p:spPr>
-          <a:xfrm>
-            <a:off x="7397496" y="1645920"/>
-            <a:ext cx="1783080" cy="411480"/>
-          </a:xfrm>
-          <a:prstGeom prst="roundRect">
-            <a:avLst/>
-          </a:prstGeom>
-          <a:solidFill>
-            <a:srgbClr val="F59E0B"/>
-          </a:solidFill>
-          <a:ln>
-            <a:noFill/>
-          </a:ln>
-        </p:spPr>
-        <p:style>
-          <a:lnRef idx="1">
-            <a:schemeClr val="accent1"/>
-          </a:lnRef>
-          <a:fillRef idx="3">
-            <a:schemeClr val="accent1"/>
-          </a:fillRef>
-          <a:effectRef idx="2">
-            <a:schemeClr val="accent1"/>
-          </a:effectRef>
-          <a:fontRef idx="minor">
-            <a:schemeClr val="lt1"/>
-          </a:fontRef>
-        </p:style>
-        <p:txBody>
-          <a:bodyPr rtlCol="0" anchor="ctr"/>
-          <a:lstStyle/>
-          <a:p>
-            <a:pPr algn="ctr">
-              <a:defRPr sz="1000" b="1">
-                <a:solidFill>
-                  <a:srgbClr val="FFFFFF"/>
-                </a:solidFill>
-              </a:defRPr>
-            </a:pPr>
-            <a:r>
-              <a:t>STEP 4</a:t>
-            </a:r>
-          </a:p>
-        </p:txBody>
-      </p:sp>
-      <p:sp>
-        <p:nvSpPr>
-          <p:cNvPr id="21" name="TextBox 20"/>
-          <p:cNvSpPr txBox="1"/>
-          <p:nvPr/>
-        </p:nvSpPr>
-        <p:spPr>
-          <a:xfrm>
-            <a:off x="7397496" y="2194560"/>
-            <a:ext cx="1783080" cy="3657600"/>
-          </a:xfrm>
-          <a:prstGeom prst="rect">
-            <a:avLst/>
-          </a:prstGeom>
-          <a:noFill/>
-        </p:spPr>
-        <p:txBody>
-          <a:bodyPr wrap="square">
-            <a:spAutoFit/>
-          </a:bodyPr>
-          <a:lstStyle/>
-          <a:p>
-            <a:pPr>
-              <a:defRPr sz="1200" b="1">
-                <a:solidFill>
-                  <a:srgbClr val="F8FAFC"/>
-                </a:solidFill>
-              </a:defRPr>
-            </a:pPr>
-            <a:r>
-              <a:t>4. Canteen Vendor</a:t>
-            </a:r>
-          </a:p>
-          <a:p>
-            <a:pPr>
-              <a:spcBef>
-                <a:spcPts val="800"/>
-              </a:spcBef>
-              <a:defRPr sz="950">
-                <a:solidFill>
-                  <a:srgbClr val="94A3B8"/>
-                </a:solidFill>
-              </a:defRPr>
-            </a:pPr>
-            <a:r>
-              <a:t>Confirms pricing, prepares items, requests modifications if needed.</a:t>
-            </a:r>
-          </a:p>
-        </p:txBody>
-      </p:sp>
-      <p:sp>
-        <p:nvSpPr>
-          <p:cNvPr id="22" name="Right Arrow 21"/>
-          <p:cNvSpPr/>
-          <p:nvPr/>
-        </p:nvSpPr>
-        <p:spPr>
-          <a:xfrm>
-            <a:off x="9345167" y="3566160"/>
-            <a:ext cx="146304" cy="219456"/>
-          </a:xfrm>
-          <a:prstGeom prst="rightArrow">
-            <a:avLst/>
-          </a:prstGeom>
-          <a:solidFill>
-            <a:srgbClr val="60A5FA"/>
-          </a:solidFill>
-          <a:ln>
-            <a:noFill/>
-          </a:ln>
-        </p:spPr>
-        <p:style>
-          <a:lnRef idx="1">
-            <a:schemeClr val="accent1"/>
-          </a:lnRef>
-          <a:fillRef idx="3">
-            <a:schemeClr val="accent1"/>
-          </a:fillRef>
-          <a:effectRef idx="2">
-            <a:schemeClr val="accent1"/>
-          </a:effectRef>
-          <a:fontRef idx="minor">
-            <a:schemeClr val="lt1"/>
-          </a:fontRef>
-        </p:style>
-        <p:txBody>
-          <a:bodyPr rtlCol="0" anchor="ctr"/>
-          <a:lstStyle/>
-          <a:p>
-            <a:pPr algn="ctr"/>
-          </a:p>
-        </p:txBody>
-      </p:sp>
-      <p:sp>
-        <p:nvSpPr>
-          <p:cNvPr id="23" name="Rounded Rectangle 22"/>
-          <p:cNvSpPr/>
-          <p:nvPr/>
-        </p:nvSpPr>
-        <p:spPr>
-          <a:xfrm>
-            <a:off x="9436608" y="1463040"/>
-            <a:ext cx="2057400" cy="4572000"/>
-          </a:xfrm>
-          <a:prstGeom prst="roundRect">
-            <a:avLst/>
-          </a:prstGeom>
-          <a:solidFill>
-            <a:srgbClr val="1E293B"/>
-          </a:solidFill>
-          <a:ln>
-            <a:solidFill>
-              <a:srgbClr val="334155"/>
-            </a:solidFill>
-          </a:ln>
-        </p:spPr>
-        <p:style>
-          <a:lnRef idx="1">
-            <a:schemeClr val="accent1"/>
-          </a:lnRef>
-          <a:fillRef idx="3">
-            <a:schemeClr val="accent1"/>
-          </a:fillRef>
-          <a:effectRef idx="2">
-            <a:schemeClr val="accent1"/>
-          </a:effectRef>
-          <a:fontRef idx="minor">
-            <a:schemeClr val="lt1"/>
-          </a:fontRef>
-        </p:style>
-        <p:txBody>
-          <a:bodyPr rtlCol="0" anchor="ctr"/>
-          <a:lstStyle/>
-          <a:p>
-            <a:pPr algn="ctr"/>
-          </a:p>
-        </p:txBody>
-      </p:sp>
-      <p:sp>
-        <p:nvSpPr>
-          <p:cNvPr id="24" name="Rounded Rectangle 23"/>
-          <p:cNvSpPr/>
-          <p:nvPr/>
-        </p:nvSpPr>
-        <p:spPr>
-          <a:xfrm>
-            <a:off x="9573768" y="1645920"/>
-            <a:ext cx="1783080" cy="411480"/>
-          </a:xfrm>
-          <a:prstGeom prst="roundRect">
-            <a:avLst/>
-          </a:prstGeom>
-          <a:solidFill>
-            <a:srgbClr val="10B981"/>
-          </a:solidFill>
-          <a:ln>
-            <a:noFill/>
-          </a:ln>
-        </p:spPr>
-        <p:style>
-          <a:lnRef idx="1">
-            <a:schemeClr val="accent1"/>
-          </a:lnRef>
-          <a:fillRef idx="3">
-            <a:schemeClr val="accent1"/>
-          </a:fillRef>
-          <a:effectRef idx="2">
-            <a:schemeClr val="accent1"/>
-          </a:effectRef>
-          <a:fontRef idx="minor">
-            <a:schemeClr val="lt1"/>
-          </a:fontRef>
-        </p:style>
-        <p:txBody>
-          <a:bodyPr rtlCol="0" anchor="ctr"/>
-          <a:lstStyle/>
-          <a:p>
-            <a:pPr algn="ctr">
-              <a:defRPr sz="1000" b="1">
-                <a:solidFill>
-                  <a:srgbClr val="FFFFFF"/>
-                </a:solidFill>
-              </a:defRPr>
-            </a:pPr>
-            <a:r>
-              <a:t>STEP 5</a:t>
-            </a:r>
-          </a:p>
-        </p:txBody>
-      </p:sp>
-      <p:sp>
-        <p:nvSpPr>
-          <p:cNvPr id="25" name="TextBox 24"/>
-          <p:cNvSpPr txBox="1"/>
-          <p:nvPr/>
-        </p:nvSpPr>
-        <p:spPr>
-          <a:xfrm>
-            <a:off x="9573768" y="2194560"/>
-            <a:ext cx="1783080" cy="3657600"/>
-          </a:xfrm>
-          <a:prstGeom prst="rect">
-            <a:avLst/>
-          </a:prstGeom>
-          <a:noFill/>
-        </p:spPr>
-        <p:txBody>
-          <a:bodyPr wrap="square">
-            <a:spAutoFit/>
-          </a:bodyPr>
-          <a:lstStyle/>
-          <a:p>
-            <a:pPr>
-              <a:defRPr sz="1200" b="1">
-                <a:solidFill>
-                  <a:srgbClr val="F8FAFC"/>
-                </a:solidFill>
-              </a:defRPr>
-            </a:pPr>
-            <a:r>
-              <a:t>5. Final Settlement</a:t>
-            </a:r>
-          </a:p>
-          <a:p>
-            <a:pPr>
-              <a:spcBef>
-                <a:spcPts val="800"/>
-              </a:spcBef>
-              <a:defRPr sz="950">
-                <a:solidFill>
-                  <a:srgbClr val="94A3B8"/>
-                </a:solidFill>
-              </a:defRPr>
-            </a:pPr>
-            <a:r>
-              <a:t>Consolidates all sub-bills, generates verified QR invoice &amp; audit entry.</a:t>
+              <a:defRPr sz="950" b="1">
+                <a:solidFill>
+                  <a:srgbClr val="60A5FA"/>
+                </a:solidFill>
+                <a:latin typeface="Arial"/>
+              </a:defRPr>
+            </a:pPr>
+            <a:r>
+              <a:t>📸 End-to-End Order Requisition &amp; Verification Data Flow</a:t>
             </a:r>
           </a:p>
         </p:txBody>
@@ -9116,7 +8438,7 @@
 </file>
 
 <file path=ppt/slides/slide6.xml><?xml version="1.0" encoding="utf-8"?>
-<p:sld xmlns:a="http://schemas.openxmlformats.org/drawingml/2006/main" xmlns:p="http://schemas.openxmlformats.org/presentationml/2006/main" xmlns:r="http://schemas.openxmlformats.org/officeDocument/2006/relationships">
+<p:sld xmlns:a="http://schemas.openxmlformats.org/drawingml/2006/main" xmlns:r="http://schemas.openxmlformats.org/officeDocument/2006/relationships" xmlns:p="http://schemas.openxmlformats.org/presentationml/2006/main">
   <p:cSld>
     <p:spTree>
       <p:nvGrpSpPr>
@@ -9124,7 +8446,14 @@
         <p:cNvGrpSpPr/>
         <p:nvPr/>
       </p:nvGrpSpPr>
-      <p:grpSpPr/>
+      <p:grpSpPr>
+        <a:xfrm>
+          <a:off x="0" y="0"/>
+          <a:ext cx="0" cy="0"/>
+          <a:chOff x="0" y="0"/>
+          <a:chExt cx="0" cy="0"/>
+        </a:xfrm>
+      </p:grpSpPr>
       <p:sp>
         <p:nvSpPr>
           <p:cNvPr id="2" name="Rectangle 1"/>
@@ -9165,6 +8494,7 @@
           <a:lstStyle/>
           <a:p>
             <a:pPr algn="ctr"/>
+            <a:endParaRPr/>
           </a:p>
         </p:txBody>
       </p:sp>
@@ -9185,7 +8515,7 @@
           <a:noFill/>
         </p:spPr>
         <p:txBody>
-          <a:bodyPr wrap="square" lIns="0" rIns="0" tIns="0" bIns="0">
+          <a:bodyPr wrap="square" lIns="0" tIns="0" rIns="0" bIns="0">
             <a:spAutoFit/>
           </a:bodyPr>
           <a:lstStyle/>
@@ -9221,7 +8551,7 @@
           <a:noFill/>
         </p:spPr>
         <p:txBody>
-          <a:bodyPr wrap="square" lIns="0" rIns="0" tIns="0" bIns="0">
+          <a:bodyPr wrap="square" lIns="0" tIns="0" rIns="0" bIns="0">
             <a:spAutoFit/>
           </a:bodyPr>
           <a:lstStyle/>
@@ -9235,7 +8565,7 @@
               </a:defRPr>
             </a:pPr>
             <a:r>
-              <a:t>Coordinator Experience: Multi-Vendor Requisition</a:t>
+              <a:t>Coordinator Experience: Multi-Vendor Requisition &amp; Tracking</a:t>
             </a:r>
           </a:p>
         </p:txBody>
@@ -9280,6 +8610,7 @@
           <a:lstStyle/>
           <a:p>
             <a:pPr algn="ctr"/>
+            <a:endParaRPr/>
           </a:p>
         </p:txBody>
       </p:sp>
@@ -9300,7 +8631,7 @@
           <a:noFill/>
         </p:spPr>
         <p:txBody>
-          <a:bodyPr wrap="none" lIns="0" rIns="0" tIns="0" bIns="0">
+          <a:bodyPr wrap="none" lIns="0" tIns="0" rIns="0" bIns="0">
             <a:spAutoFit/>
           </a:bodyPr>
           <a:lstStyle/>
@@ -9328,7 +8659,7 @@
         <p:spPr>
           <a:xfrm>
             <a:off x="731520" y="1463040"/>
-            <a:ext cx="5303520" cy="1371600"/>
+            <a:ext cx="4937760" cy="1371600"/>
           </a:xfrm>
           <a:prstGeom prst="roundRect">
             <a:avLst/>
@@ -9361,6 +8692,7 @@
           <a:lstStyle/>
           <a:p>
             <a:pPr algn="ctr"/>
+            <a:endParaRPr/>
           </a:p>
         </p:txBody>
       </p:sp>
@@ -9373,7 +8705,7 @@
         <p:spPr>
           <a:xfrm>
             <a:off x="960120" y="1645920"/>
-            <a:ext cx="4846320" cy="1005840"/>
+            <a:ext cx="4480560" cy="1005840"/>
           </a:xfrm>
           <a:prstGeom prst="rect">
             <a:avLst/>
@@ -9381,7 +8713,7 @@
           <a:noFill/>
         </p:spPr>
         <p:txBody>
-          <a:bodyPr wrap="square" lIns="0" rIns="0" tIns="0" bIns="0">
+          <a:bodyPr wrap="square" lIns="0" tIns="0" rIns="0" bIns="0">
             <a:spAutoFit/>
           </a:bodyPr>
           <a:lstStyle/>
@@ -9441,7 +8773,7 @@
         <p:spPr>
           <a:xfrm>
             <a:off x="731520" y="2971800"/>
-            <a:ext cx="5303520" cy="1371600"/>
+            <a:ext cx="4937760" cy="1371600"/>
           </a:xfrm>
           <a:prstGeom prst="roundRect">
             <a:avLst/>
@@ -9474,6 +8806,7 @@
           <a:lstStyle/>
           <a:p>
             <a:pPr algn="ctr"/>
+            <a:endParaRPr/>
           </a:p>
         </p:txBody>
       </p:sp>
@@ -9486,7 +8819,7 @@
         <p:spPr>
           <a:xfrm>
             <a:off x="960120" y="3154680"/>
-            <a:ext cx="4846320" cy="1005840"/>
+            <a:ext cx="4480560" cy="1005840"/>
           </a:xfrm>
           <a:prstGeom prst="rect">
             <a:avLst/>
@@ -9494,7 +8827,7 @@
           <a:noFill/>
         </p:spPr>
         <p:txBody>
-          <a:bodyPr wrap="square" lIns="0" rIns="0" tIns="0" bIns="0">
+          <a:bodyPr wrap="square" lIns="0" tIns="0" rIns="0" bIns="0">
             <a:spAutoFit/>
           </a:bodyPr>
           <a:lstStyle/>
@@ -9540,7 +8873,7 @@
               </a:defRPr>
             </a:pPr>
             <a:r>
-              <a:t>• Automated subtotal calculations with instant budget summary.</a:t>
+              <a:t>• Automated line item price calculations with instant budget summary.</a:t>
             </a:r>
           </a:p>
         </p:txBody>
@@ -9554,7 +8887,7 @@
         <p:spPr>
           <a:xfrm>
             <a:off x="731520" y="4480560"/>
-            <a:ext cx="5303520" cy="1371600"/>
+            <a:ext cx="4937760" cy="1371600"/>
           </a:xfrm>
           <a:prstGeom prst="roundRect">
             <a:avLst/>
@@ -9587,6 +8920,7 @@
           <a:lstStyle/>
           <a:p>
             <a:pPr algn="ctr"/>
+            <a:endParaRPr/>
           </a:p>
         </p:txBody>
       </p:sp>
@@ -9599,7 +8933,7 @@
         <p:spPr>
           <a:xfrm>
             <a:off x="960120" y="4663440"/>
-            <a:ext cx="4846320" cy="1005840"/>
+            <a:ext cx="4480560" cy="1005840"/>
           </a:xfrm>
           <a:prstGeom prst="rect">
             <a:avLst/>
@@ -9607,7 +8941,7 @@
           <a:noFill/>
         </p:spPr>
         <p:txBody>
-          <a:bodyPr wrap="square" lIns="0" rIns="0" tIns="0" bIns="0">
+          <a:bodyPr wrap="square" lIns="0" tIns="0" rIns="0" bIns="0">
             <a:spAutoFit/>
           </a:bodyPr>
           <a:lstStyle/>
@@ -9621,7 +8955,7 @@
               </a:defRPr>
             </a:pPr>
             <a:r>
-              <a:t>Live Order Tracking &amp; Rejection Visibility</a:t>
+              <a:t>Pre-DCR Modification &amp; Live Tracking</a:t>
             </a:r>
           </a:p>
           <a:p>
@@ -9637,7 +8971,7 @@
               </a:defRPr>
             </a:pPr>
             <a:r>
-              <a:t>• Visual order stepper displaying current stage in approval lifecycle.</a:t>
+              <a:t>• Coordinators can modify or cancel orders prior to final DCR audit clearance.</a:t>
             </a:r>
           </a:p>
           <a:p>
@@ -9653,7 +8987,7 @@
               </a:defRPr>
             </a:pPr>
             <a:r>
-              <a:t>• Detailed rejection remarks with immediate re-submission capabilities.</a:t>
+              <a:t>• Visual order stepper displaying real-time stage in approval lifecycle.</a:t>
             </a:r>
           </a:p>
         </p:txBody>
@@ -9666,8 +9000,8 @@
         </p:nvSpPr>
         <p:spPr>
           <a:xfrm>
-            <a:off x="6217920" y="1463040"/>
-            <a:ext cx="5242255" cy="4480560"/>
+            <a:off x="5815584" y="1426464"/>
+            <a:ext cx="5681167" cy="4553712"/>
           </a:xfrm>
           <a:prstGeom prst="roundRect">
             <a:avLst/>
@@ -9700,19 +9034,44 @@
           <a:lstStyle/>
           <a:p>
             <a:pPr algn="ctr"/>
-          </a:p>
-        </p:txBody>
-      </p:sp>
-      <p:sp>
-        <p:nvSpPr>
-          <p:cNvPr id="14" name="TextBox 13"/>
+            <a:endParaRPr/>
+          </a:p>
+        </p:txBody>
+      </p:sp>
+      <p:pic>
+        <p:nvPicPr>
+          <p:cNvPr id="14" name="Picture 13" descr="media_1787155691765.png"/>
+          <p:cNvPicPr>
+            <a:picLocks noChangeAspect="1"/>
+          </p:cNvPicPr>
+          <p:nvPr/>
+        </p:nvPicPr>
+        <p:blipFill>
+          <a:blip r:embed="rId2"/>
+          <a:stretch>
+            <a:fillRect/>
+          </a:stretch>
+        </p:blipFill>
+        <p:spPr>
+          <a:xfrm>
+            <a:off x="5762842" y="1399032"/>
+            <a:ext cx="5733909" cy="4617720"/>
+          </a:xfrm>
+          <a:prstGeom prst="rect">
+            <a:avLst/>
+          </a:prstGeom>
+        </p:spPr>
+      </p:pic>
+      <p:sp>
+        <p:nvSpPr>
+          <p:cNvPr id="15" name="TextBox 14"/>
           <p:cNvSpPr txBox="1"/>
           <p:nvPr/>
         </p:nvSpPr>
         <p:spPr>
           <a:xfrm>
-            <a:off x="6400800" y="3154680"/>
-            <a:ext cx="4876495" cy="1097280"/>
+            <a:off x="5852160" y="6016752"/>
+            <a:ext cx="5608015" cy="274320"/>
           </a:xfrm>
           <a:prstGeom prst="rect">
             <a:avLst/>
@@ -9720,13 +9079,13 @@
           <a:noFill/>
         </p:spPr>
         <p:txBody>
-          <a:bodyPr wrap="square" lIns="0" rIns="0" tIns="0" bIns="0">
+          <a:bodyPr wrap="none" lIns="0" tIns="0" rIns="0" bIns="0">
             <a:spAutoFit/>
           </a:bodyPr>
           <a:lstStyle/>
           <a:p>
             <a:pPr algn="ctr">
-              <a:defRPr sz="1200" b="1">
+              <a:defRPr sz="950" b="1">
                 <a:solidFill>
                   <a:srgbClr val="60A5FA"/>
                 </a:solidFill>
@@ -9734,33 +9093,7 @@
               </a:defRPr>
             </a:pPr>
             <a:r>
-              <a:t>📸 Coordinator Portal UI Screenshot</a:t>
-            </a:r>
-          </a:p>
-          <a:p>
-            <a:pPr algn="ctr">
-              <a:defRPr sz="950">
-                <a:solidFill>
-                  <a:srgbClr val="94A3B8"/>
-                </a:solidFill>
-                <a:latin typeface="Arial"/>
-              </a:defRPr>
-            </a:pPr>
-            <a:r>
-              <a:t>Insert Coordinator Draft &amp; Tracking Page Screenshot</a:t>
-            </a:r>
-          </a:p>
-          <a:p>
-            <a:pPr algn="ctr">
-              <a:defRPr sz="850" i="1">
-                <a:solidFill>
-                  <a:srgbClr val="94A3B8"/>
-                </a:solidFill>
-                <a:latin typeface="Arial"/>
-              </a:defRPr>
-            </a:pPr>
-            <a:r>
-              <a:t>(Right Click → Change Picture / Paste Screenshot)</a:t>
+              <a:t>📸 Coordinator Dashboard &amp; Requisition Interface</a:t>
             </a:r>
           </a:p>
         </p:txBody>
@@ -9774,7 +9107,7 @@
 </file>
 
 <file path=ppt/slides/slide7.xml><?xml version="1.0" encoding="utf-8"?>
-<p:sld xmlns:a="http://schemas.openxmlformats.org/drawingml/2006/main" xmlns:p="http://schemas.openxmlformats.org/presentationml/2006/main" xmlns:r="http://schemas.openxmlformats.org/officeDocument/2006/relationships">
+<p:sld xmlns:a="http://schemas.openxmlformats.org/drawingml/2006/main" xmlns:r="http://schemas.openxmlformats.org/officeDocument/2006/relationships" xmlns:p="http://schemas.openxmlformats.org/presentationml/2006/main">
   <p:cSld>
     <p:spTree>
       <p:nvGrpSpPr>
@@ -9782,7 +9115,14 @@
         <p:cNvGrpSpPr/>
         <p:nvPr/>
       </p:nvGrpSpPr>
-      <p:grpSpPr/>
+      <p:grpSpPr>
+        <a:xfrm>
+          <a:off x="0" y="0"/>
+          <a:ext cx="0" cy="0"/>
+          <a:chOff x="0" y="0"/>
+          <a:chExt cx="0" cy="0"/>
+        </a:xfrm>
+      </p:grpSpPr>
       <p:sp>
         <p:nvSpPr>
           <p:cNvPr id="2" name="Rectangle 1"/>
@@ -9823,6 +9163,7 @@
           <a:lstStyle/>
           <a:p>
             <a:pPr algn="ctr"/>
+            <a:endParaRPr/>
           </a:p>
         </p:txBody>
       </p:sp>
@@ -9843,7 +9184,7 @@
           <a:noFill/>
         </p:spPr>
         <p:txBody>
-          <a:bodyPr wrap="square" lIns="0" rIns="0" tIns="0" bIns="0">
+          <a:bodyPr wrap="square" lIns="0" tIns="0" rIns="0" bIns="0">
             <a:spAutoFit/>
           </a:bodyPr>
           <a:lstStyle/>
@@ -9879,7 +9220,7 @@
           <a:noFill/>
         </p:spPr>
         <p:txBody>
-          <a:bodyPr wrap="square" lIns="0" rIns="0" tIns="0" bIns="0">
+          <a:bodyPr wrap="square" lIns="0" tIns="0" rIns="0" bIns="0">
             <a:spAutoFit/>
           </a:bodyPr>
           <a:lstStyle/>
@@ -9893,7 +9234,7 @@
               </a:defRPr>
             </a:pPr>
             <a:r>
-              <a:t>Leadership Governance: Principal &amp; DCR Review</a:t>
+              <a:t>Leadership Governance: Principal &amp; DCR Review Controls</a:t>
             </a:r>
           </a:p>
         </p:txBody>
@@ -9938,6 +9279,7 @@
           <a:lstStyle/>
           <a:p>
             <a:pPr algn="ctr"/>
+            <a:endParaRPr/>
           </a:p>
         </p:txBody>
       </p:sp>
@@ -9958,7 +9300,7 @@
           <a:noFill/>
         </p:spPr>
         <p:txBody>
-          <a:bodyPr wrap="none" lIns="0" rIns="0" tIns="0" bIns="0">
+          <a:bodyPr wrap="none" lIns="0" tIns="0" rIns="0" bIns="0">
             <a:spAutoFit/>
           </a:bodyPr>
           <a:lstStyle/>
@@ -9986,7 +9328,7 @@
         <p:spPr>
           <a:xfrm>
             <a:off x="731520" y="1463040"/>
-            <a:ext cx="5303520" cy="2148840"/>
+            <a:ext cx="4937760" cy="2148840"/>
           </a:xfrm>
           <a:prstGeom prst="roundRect">
             <a:avLst/>
@@ -10019,6 +9361,7 @@
           <a:lstStyle/>
           <a:p>
             <a:pPr algn="ctr"/>
+            <a:endParaRPr/>
           </a:p>
         </p:txBody>
       </p:sp>
@@ -10031,7 +9374,7 @@
         <p:spPr>
           <a:xfrm>
             <a:off x="960120" y="1645920"/>
-            <a:ext cx="4846320" cy="1783080"/>
+            <a:ext cx="4480560" cy="1783080"/>
           </a:xfrm>
           <a:prstGeom prst="rect">
             <a:avLst/>
@@ -10039,7 +9382,7 @@
           <a:noFill/>
         </p:spPr>
         <p:txBody>
-          <a:bodyPr wrap="square" lIns="0" rIns="0" tIns="0" bIns="0">
+          <a:bodyPr wrap="square" lIns="0" tIns="0" rIns="0" bIns="0">
             <a:spAutoFit/>
           </a:bodyPr>
           <a:lstStyle/>
@@ -10069,7 +9412,7 @@
               </a:defRPr>
             </a:pPr>
             <a:r>
-              <a:t>• Multi-department supervisors (e.g. Diploma + Degree) review pending requisitions.</a:t>
+              <a:t>• Multi-department supervisors (e.g. Diploma + Degree) review pending queues.</a:t>
             </a:r>
           </a:p>
           <a:p>
@@ -10085,7 +9428,7 @@
               </a:defRPr>
             </a:pPr>
             <a:r>
-              <a:t>• One-click Approve / Reject with mandatory auditable remarks.</a:t>
+              <a:t>• 1-Click Approve / Reject with mandatory auditable remarks.</a:t>
             </a:r>
           </a:p>
           <a:p>
@@ -10101,7 +9444,7 @@
               </a:defRPr>
             </a:pPr>
             <a:r>
-              <a:t>• Direct-order privilege allowing Principals to draft urgent VIP orders directly to DCR.</a:t>
+              <a:t>• Direct-order privilege allowing Principals to draft urgent VIP requisitions directly.</a:t>
             </a:r>
           </a:p>
         </p:txBody>
@@ -10115,7 +9458,7 @@
         <p:spPr>
           <a:xfrm>
             <a:off x="731520" y="3749039"/>
-            <a:ext cx="5303520" cy="2148840"/>
+            <a:ext cx="4937760" cy="2148840"/>
           </a:xfrm>
           <a:prstGeom prst="roundRect">
             <a:avLst/>
@@ -10148,6 +9491,7 @@
           <a:lstStyle/>
           <a:p>
             <a:pPr algn="ctr"/>
+            <a:endParaRPr/>
           </a:p>
         </p:txBody>
       </p:sp>
@@ -10160,7 +9504,7 @@
         <p:spPr>
           <a:xfrm>
             <a:off x="960120" y="3931919"/>
-            <a:ext cx="4846320" cy="1783080"/>
+            <a:ext cx="4480560" cy="1783080"/>
           </a:xfrm>
           <a:prstGeom prst="rect">
             <a:avLst/>
@@ -10168,7 +9512,7 @@
           <a:noFill/>
         </p:spPr>
         <p:txBody>
-          <a:bodyPr wrap="square" lIns="0" rIns="0" tIns="0" bIns="0">
+          <a:bodyPr wrap="square" lIns="0" tIns="0" rIns="0" bIns="0">
             <a:spAutoFit/>
           </a:bodyPr>
           <a:lstStyle/>
@@ -10243,8 +9587,8 @@
         </p:nvSpPr>
         <p:spPr>
           <a:xfrm>
-            <a:off x="6217920" y="1463040"/>
-            <a:ext cx="5242255" cy="4480560"/>
+            <a:off x="5815584" y="1426464"/>
+            <a:ext cx="5681167" cy="4553712"/>
           </a:xfrm>
           <a:prstGeom prst="roundRect">
             <a:avLst/>
@@ -10277,19 +9621,44 @@
           <a:lstStyle/>
           <a:p>
             <a:pPr algn="ctr"/>
-          </a:p>
-        </p:txBody>
-      </p:sp>
-      <p:sp>
-        <p:nvSpPr>
-          <p:cNvPr id="12" name="TextBox 11"/>
+            <a:endParaRPr/>
+          </a:p>
+        </p:txBody>
+      </p:sp>
+      <p:pic>
+        <p:nvPicPr>
+          <p:cNvPr id="12" name="Picture 11" descr="media_1787155691787.png"/>
+          <p:cNvPicPr>
+            <a:picLocks noChangeAspect="1"/>
+          </p:cNvPicPr>
+          <p:nvPr/>
+        </p:nvPicPr>
+        <p:blipFill>
+          <a:blip r:embed="rId2"/>
+          <a:stretch>
+            <a:fillRect/>
+          </a:stretch>
+        </p:blipFill>
+        <p:spPr>
+          <a:xfrm>
+            <a:off x="5760600" y="1353312"/>
+            <a:ext cx="5791134" cy="4626864"/>
+          </a:xfrm>
+          <a:prstGeom prst="rect">
+            <a:avLst/>
+          </a:prstGeom>
+        </p:spPr>
+      </p:pic>
+      <p:sp>
+        <p:nvSpPr>
+          <p:cNvPr id="13" name="TextBox 12"/>
           <p:cNvSpPr txBox="1"/>
           <p:nvPr/>
         </p:nvSpPr>
         <p:spPr>
           <a:xfrm>
-            <a:off x="6400800" y="3154680"/>
-            <a:ext cx="4876495" cy="1097280"/>
+            <a:off x="5852160" y="6016752"/>
+            <a:ext cx="5608015" cy="274320"/>
           </a:xfrm>
           <a:prstGeom prst="rect">
             <a:avLst/>
@@ -10297,13 +9666,13 @@
           <a:noFill/>
         </p:spPr>
         <p:txBody>
-          <a:bodyPr wrap="square" lIns="0" rIns="0" tIns="0" bIns="0">
+          <a:bodyPr wrap="none" lIns="0" tIns="0" rIns="0" bIns="0">
             <a:spAutoFit/>
           </a:bodyPr>
           <a:lstStyle/>
           <a:p>
             <a:pPr algn="ctr">
-              <a:defRPr sz="1200" b="1">
+              <a:defRPr sz="950" b="1">
                 <a:solidFill>
                   <a:srgbClr val="60A5FA"/>
                 </a:solidFill>
@@ -10311,33 +9680,7 @@
               </a:defRPr>
             </a:pPr>
             <a:r>
-              <a:t>📸 Principal / DCR Review UI Screenshot</a:t>
-            </a:r>
-          </a:p>
-          <a:p>
-            <a:pPr algn="ctr">
-              <a:defRPr sz="950">
-                <a:solidFill>
-                  <a:srgbClr val="94A3B8"/>
-                </a:solidFill>
-                <a:latin typeface="Arial"/>
-              </a:defRPr>
-            </a:pPr>
-            <a:r>
-              <a:t>Insert Principal Approvals &amp; Audit Page Screenshot</a:t>
-            </a:r>
-          </a:p>
-          <a:p>
-            <a:pPr algn="ctr">
-              <a:defRPr sz="850" i="1">
-                <a:solidFill>
-                  <a:srgbClr val="94A3B8"/>
-                </a:solidFill>
-                <a:latin typeface="Arial"/>
-              </a:defRPr>
-            </a:pPr>
-            <a:r>
-              <a:t>(Right Click → Change Picture / Paste Screenshot)</a:t>
+              <a:t>📸 Principal Requisition Review &amp; Governance Queue</a:t>
             </a:r>
           </a:p>
         </p:txBody>
@@ -10351,7 +9694,7 @@
 </file>
 
 <file path=ppt/slides/slide8.xml><?xml version="1.0" encoding="utf-8"?>
-<p:sld xmlns:a="http://schemas.openxmlformats.org/drawingml/2006/main" xmlns:p="http://schemas.openxmlformats.org/presentationml/2006/main" xmlns:r="http://schemas.openxmlformats.org/officeDocument/2006/relationships">
+<p:sld xmlns:a="http://schemas.openxmlformats.org/drawingml/2006/main" xmlns:r="http://schemas.openxmlformats.org/officeDocument/2006/relationships" xmlns:p="http://schemas.openxmlformats.org/presentationml/2006/main">
   <p:cSld>
     <p:spTree>
       <p:nvGrpSpPr>
@@ -10359,7 +9702,14 @@
         <p:cNvGrpSpPr/>
         <p:nvPr/>
       </p:nvGrpSpPr>
-      <p:grpSpPr/>
+      <p:grpSpPr>
+        <a:xfrm>
+          <a:off x="0" y="0"/>
+          <a:ext cx="0" cy="0"/>
+          <a:chOff x="0" y="0"/>
+          <a:chExt cx="0" cy="0"/>
+        </a:xfrm>
+      </p:grpSpPr>
       <p:sp>
         <p:nvSpPr>
           <p:cNvPr id="2" name="Rectangle 1"/>
@@ -10400,6 +9750,7 @@
           <a:lstStyle/>
           <a:p>
             <a:pPr algn="ctr"/>
+            <a:endParaRPr/>
           </a:p>
         </p:txBody>
       </p:sp>
@@ -10420,7 +9771,7 @@
           <a:noFill/>
         </p:spPr>
         <p:txBody>
-          <a:bodyPr wrap="square" lIns="0" rIns="0" tIns="0" bIns="0">
+          <a:bodyPr wrap="square" lIns="0" tIns="0" rIns="0" bIns="0">
             <a:spAutoFit/>
           </a:bodyPr>
           <a:lstStyle/>
@@ -10456,7 +9807,7 @@
           <a:noFill/>
         </p:spPr>
         <p:txBody>
-          <a:bodyPr wrap="square" lIns="0" rIns="0" tIns="0" bIns="0">
+          <a:bodyPr wrap="square" lIns="0" tIns="0" rIns="0" bIns="0">
             <a:spAutoFit/>
           </a:bodyPr>
           <a:lstStyle/>
@@ -10515,6 +9866,7 @@
           <a:lstStyle/>
           <a:p>
             <a:pPr algn="ctr"/>
+            <a:endParaRPr/>
           </a:p>
         </p:txBody>
       </p:sp>
@@ -10535,7 +9887,7 @@
           <a:noFill/>
         </p:spPr>
         <p:txBody>
-          <a:bodyPr wrap="none" lIns="0" rIns="0" tIns="0" bIns="0">
+          <a:bodyPr wrap="none" lIns="0" tIns="0" rIns="0" bIns="0">
             <a:spAutoFit/>
           </a:bodyPr>
           <a:lstStyle/>
@@ -10563,7 +9915,7 @@
         <p:spPr>
           <a:xfrm>
             <a:off x="731520" y="1463040"/>
-            <a:ext cx="5303520" cy="1371600"/>
+            <a:ext cx="4937760" cy="1371600"/>
           </a:xfrm>
           <a:prstGeom prst="roundRect">
             <a:avLst/>
@@ -10596,6 +9948,7 @@
           <a:lstStyle/>
           <a:p>
             <a:pPr algn="ctr"/>
+            <a:endParaRPr/>
           </a:p>
         </p:txBody>
       </p:sp>
@@ -10608,7 +9961,7 @@
         <p:spPr>
           <a:xfrm>
             <a:off x="960120" y="1645920"/>
-            <a:ext cx="4846320" cy="1005840"/>
+            <a:ext cx="4480560" cy="1005840"/>
           </a:xfrm>
           <a:prstGeom prst="rect">
             <a:avLst/>
@@ -10616,7 +9969,7 @@
           <a:noFill/>
         </p:spPr>
         <p:txBody>
-          <a:bodyPr wrap="square" lIns="0" rIns="0" tIns="0" bIns="0">
+          <a:bodyPr wrap="square" lIns="0" tIns="0" rIns="0" bIns="0">
             <a:spAutoFit/>
           </a:bodyPr>
           <a:lstStyle/>
@@ -10692,7 +10045,7 @@
         <p:spPr>
           <a:xfrm>
             <a:off x="731520" y="2971800"/>
-            <a:ext cx="5303520" cy="1371600"/>
+            <a:ext cx="4937760" cy="1371600"/>
           </a:xfrm>
           <a:prstGeom prst="roundRect">
             <a:avLst/>
@@ -10725,6 +10078,7 @@
           <a:lstStyle/>
           <a:p>
             <a:pPr algn="ctr"/>
+            <a:endParaRPr/>
           </a:p>
         </p:txBody>
       </p:sp>
@@ -10737,7 +10091,7 @@
         <p:spPr>
           <a:xfrm>
             <a:off x="960120" y="3154680"/>
-            <a:ext cx="4846320" cy="1005840"/>
+            <a:ext cx="4480560" cy="1005840"/>
           </a:xfrm>
           <a:prstGeom prst="rect">
             <a:avLst/>
@@ -10745,7 +10099,7 @@
           <a:noFill/>
         </p:spPr>
         <p:txBody>
-          <a:bodyPr wrap="square" lIns="0" rIns="0" tIns="0" bIns="0">
+          <a:bodyPr wrap="square" lIns="0" tIns="0" rIns="0" bIns="0">
             <a:spAutoFit/>
           </a:bodyPr>
           <a:lstStyle/>
@@ -10805,7 +10159,7 @@
         <p:spPr>
           <a:xfrm>
             <a:off x="731520" y="4480560"/>
-            <a:ext cx="5303520" cy="1371600"/>
+            <a:ext cx="4937760" cy="1371600"/>
           </a:xfrm>
           <a:prstGeom prst="roundRect">
             <a:avLst/>
@@ -10838,6 +10192,7 @@
           <a:lstStyle/>
           <a:p>
             <a:pPr algn="ctr"/>
+            <a:endParaRPr/>
           </a:p>
         </p:txBody>
       </p:sp>
@@ -10850,7 +10205,7 @@
         <p:spPr>
           <a:xfrm>
             <a:off x="960120" y="4663440"/>
-            <a:ext cx="4846320" cy="1005840"/>
+            <a:ext cx="4480560" cy="1005840"/>
           </a:xfrm>
           <a:prstGeom prst="rect">
             <a:avLst/>
@@ -10858,7 +10213,7 @@
           <a:noFill/>
         </p:spPr>
         <p:txBody>
-          <a:bodyPr wrap="square" lIns="0" rIns="0" tIns="0" bIns="0">
+          <a:bodyPr wrap="square" lIns="0" tIns="0" rIns="0" bIns="0">
             <a:spAutoFit/>
           </a:bodyPr>
           <a:lstStyle/>
@@ -10917,8 +10272,8 @@
         </p:nvSpPr>
         <p:spPr>
           <a:xfrm>
-            <a:off x="6217920" y="1463040"/>
-            <a:ext cx="5242255" cy="4480560"/>
+            <a:off x="5815584" y="1426464"/>
+            <a:ext cx="5681167" cy="4553712"/>
           </a:xfrm>
           <a:prstGeom prst="roundRect">
             <a:avLst/>
@@ -10951,19 +10306,44 @@
           <a:lstStyle/>
           <a:p>
             <a:pPr algn="ctr"/>
-          </a:p>
-        </p:txBody>
-      </p:sp>
-      <p:sp>
-        <p:nvSpPr>
-          <p:cNvPr id="14" name="TextBox 13"/>
+            <a:endParaRPr/>
+          </a:p>
+        </p:txBody>
+      </p:sp>
+      <p:pic>
+        <p:nvPicPr>
+          <p:cNvPr id="14" name="Picture 13" descr="media_1787155691899.png"/>
+          <p:cNvPicPr>
+            <a:picLocks noChangeAspect="1"/>
+          </p:cNvPicPr>
+          <p:nvPr/>
+        </p:nvPicPr>
+        <p:blipFill>
+          <a:blip r:embed="rId2"/>
+          <a:stretch>
+            <a:fillRect/>
+          </a:stretch>
+        </p:blipFill>
+        <p:spPr>
+          <a:xfrm>
+            <a:off x="5760600" y="1389888"/>
+            <a:ext cx="5791134" cy="4626864"/>
+          </a:xfrm>
+          <a:prstGeom prst="rect">
+            <a:avLst/>
+          </a:prstGeom>
+        </p:spPr>
+      </p:pic>
+      <p:sp>
+        <p:nvSpPr>
+          <p:cNvPr id="15" name="TextBox 14"/>
           <p:cNvSpPr txBox="1"/>
           <p:nvPr/>
         </p:nvSpPr>
         <p:spPr>
           <a:xfrm>
-            <a:off x="6400800" y="3154680"/>
-            <a:ext cx="4876495" cy="1097280"/>
+            <a:off x="5852160" y="6016752"/>
+            <a:ext cx="5608015" cy="274320"/>
           </a:xfrm>
           <a:prstGeom prst="rect">
             <a:avLst/>
@@ -10971,13 +10351,13 @@
           <a:noFill/>
         </p:spPr>
         <p:txBody>
-          <a:bodyPr wrap="square" lIns="0" rIns="0" tIns="0" bIns="0">
+          <a:bodyPr wrap="none" lIns="0" tIns="0" rIns="0" bIns="0">
             <a:spAutoFit/>
           </a:bodyPr>
           <a:lstStyle/>
           <a:p>
             <a:pPr algn="ctr">
-              <a:defRPr sz="1200" b="1">
+              <a:defRPr sz="950" b="1">
                 <a:solidFill>
                   <a:srgbClr val="60A5FA"/>
                 </a:solidFill>
@@ -10985,33 +10365,7 @@
               </a:defRPr>
             </a:pPr>
             <a:r>
-              <a:t>📸 Vendor Kitchen Dashboard Screenshot</a:t>
-            </a:r>
-          </a:p>
-          <a:p>
-            <a:pPr algn="ctr">
-              <a:defRPr sz="950">
-                <a:solidFill>
-                  <a:srgbClr val="94A3B8"/>
-                </a:solidFill>
-                <a:latin typeface="Arial"/>
-              </a:defRPr>
-            </a:pPr>
-            <a:r>
-              <a:t>Insert Vendor Order Processing &amp; Menu Management Screenshot</a:t>
-            </a:r>
-          </a:p>
-          <a:p>
-            <a:pPr algn="ctr">
-              <a:defRPr sz="850" i="1">
-                <a:solidFill>
-                  <a:srgbClr val="94A3B8"/>
-                </a:solidFill>
-                <a:latin typeface="Arial"/>
-              </a:defRPr>
-            </a:pPr>
-            <a:r>
-              <a:t>(Right Click → Change Picture / Paste Screenshot)</a:t>
+              <a:t>📸 Canteen Vendor Kitchen Dashboard &amp; Orders Queue</a:t>
             </a:r>
           </a:p>
         </p:txBody>
@@ -11025,7 +10379,7 @@
 </file>
 
 <file path=ppt/slides/slide9.xml><?xml version="1.0" encoding="utf-8"?>
-<p:sld xmlns:a="http://schemas.openxmlformats.org/drawingml/2006/main" xmlns:p="http://schemas.openxmlformats.org/presentationml/2006/main" xmlns:r="http://schemas.openxmlformats.org/officeDocument/2006/relationships">
+<p:sld xmlns:a="http://schemas.openxmlformats.org/drawingml/2006/main" xmlns:r="http://schemas.openxmlformats.org/officeDocument/2006/relationships" xmlns:p="http://schemas.openxmlformats.org/presentationml/2006/main">
   <p:cSld>
     <p:spTree>
       <p:nvGrpSpPr>
@@ -11033,7 +10387,14 @@
         <p:cNvGrpSpPr/>
         <p:nvPr/>
       </p:nvGrpSpPr>
-      <p:grpSpPr/>
+      <p:grpSpPr>
+        <a:xfrm>
+          <a:off x="0" y="0"/>
+          <a:ext cx="0" cy="0"/>
+          <a:chOff x="0" y="0"/>
+          <a:chExt cx="0" cy="0"/>
+        </a:xfrm>
+      </p:grpSpPr>
       <p:sp>
         <p:nvSpPr>
           <p:cNvPr id="2" name="Rectangle 1"/>
@@ -11074,6 +10435,7 @@
           <a:lstStyle/>
           <a:p>
             <a:pPr algn="ctr"/>
+            <a:endParaRPr/>
           </a:p>
         </p:txBody>
       </p:sp>
@@ -11094,7 +10456,7 @@
           <a:noFill/>
         </p:spPr>
         <p:txBody>
-          <a:bodyPr wrap="square" lIns="0" rIns="0" tIns="0" bIns="0">
+          <a:bodyPr wrap="square" lIns="0" tIns="0" rIns="0" bIns="0">
             <a:spAutoFit/>
           </a:bodyPr>
           <a:lstStyle/>
@@ -11130,7 +10492,7 @@
           <a:noFill/>
         </p:spPr>
         <p:txBody>
-          <a:bodyPr wrap="square" lIns="0" rIns="0" tIns="0" bIns="0">
+          <a:bodyPr wrap="square" lIns="0" tIns="0" rIns="0" bIns="0">
             <a:spAutoFit/>
           </a:bodyPr>
           <a:lstStyle/>
@@ -11189,6 +10551,7 @@
           <a:lstStyle/>
           <a:p>
             <a:pPr algn="ctr"/>
+            <a:endParaRPr/>
           </a:p>
         </p:txBody>
       </p:sp>
@@ -11209,7 +10572,7 @@
           <a:noFill/>
         </p:spPr>
         <p:txBody>
-          <a:bodyPr wrap="none" lIns="0" rIns="0" tIns="0" bIns="0">
+          <a:bodyPr wrap="none" lIns="0" tIns="0" rIns="0" bIns="0">
             <a:spAutoFit/>
           </a:bodyPr>
           <a:lstStyle/>
@@ -11237,7 +10600,7 @@
         <p:spPr>
           <a:xfrm>
             <a:off x="731520" y="1463040"/>
-            <a:ext cx="5303520" cy="1371600"/>
+            <a:ext cx="4937760" cy="1371600"/>
           </a:xfrm>
           <a:prstGeom prst="roundRect">
             <a:avLst/>
@@ -11270,6 +10633,7 @@
           <a:lstStyle/>
           <a:p>
             <a:pPr algn="ctr"/>
+            <a:endParaRPr/>
           </a:p>
         </p:txBody>
       </p:sp>
@@ -11282,7 +10646,7 @@
         <p:spPr>
           <a:xfrm>
             <a:off x="960120" y="1645920"/>
-            <a:ext cx="4846320" cy="1005840"/>
+            <a:ext cx="4480560" cy="1005840"/>
           </a:xfrm>
           <a:prstGeom prst="rect">
             <a:avLst/>
@@ -11290,7 +10654,7 @@
           <a:noFill/>
         </p:spPr>
         <p:txBody>
-          <a:bodyPr wrap="square" lIns="0" rIns="0" tIns="0" bIns="0">
+          <a:bodyPr wrap="square" lIns="0" tIns="0" rIns="0" bIns="0">
             <a:spAutoFit/>
           </a:bodyPr>
           <a:lstStyle/>
@@ -11350,7 +10714,7 @@
         <p:spPr>
           <a:xfrm>
             <a:off x="731520" y="2971800"/>
-            <a:ext cx="5303520" cy="1371600"/>
+            <a:ext cx="4937760" cy="1371600"/>
           </a:xfrm>
           <a:prstGeom prst="roundRect">
             <a:avLst/>
@@ -11383,6 +10747,7 @@
           <a:lstStyle/>
           <a:p>
             <a:pPr algn="ctr"/>
+            <a:endParaRPr/>
           </a:p>
         </p:txBody>
       </p:sp>
@@ -11395,7 +10760,7 @@
         <p:spPr>
           <a:xfrm>
             <a:off x="960120" y="3154680"/>
-            <a:ext cx="4846320" cy="1005840"/>
+            <a:ext cx="4480560" cy="1005840"/>
           </a:xfrm>
           <a:prstGeom prst="rect">
             <a:avLst/>
@@ -11403,7 +10768,7 @@
           <a:noFill/>
         </p:spPr>
         <p:txBody>
-          <a:bodyPr wrap="square" lIns="0" rIns="0" tIns="0" bIns="0">
+          <a:bodyPr wrap="square" lIns="0" tIns="0" rIns="0" bIns="0">
             <a:spAutoFit/>
           </a:bodyPr>
           <a:lstStyle/>
@@ -11463,7 +10828,7 @@
         <p:spPr>
           <a:xfrm>
             <a:off x="731520" y="4480560"/>
-            <a:ext cx="5303520" cy="1371600"/>
+            <a:ext cx="4937760" cy="1371600"/>
           </a:xfrm>
           <a:prstGeom prst="roundRect">
             <a:avLst/>
@@ -11496,6 +10861,7 @@
           <a:lstStyle/>
           <a:p>
             <a:pPr algn="ctr"/>
+            <a:endParaRPr/>
           </a:p>
         </p:txBody>
       </p:sp>
@@ -11508,7 +10874,7 @@
         <p:spPr>
           <a:xfrm>
             <a:off x="960120" y="4663440"/>
-            <a:ext cx="4846320" cy="1005840"/>
+            <a:ext cx="4480560" cy="1005840"/>
           </a:xfrm>
           <a:prstGeom prst="rect">
             <a:avLst/>
@@ -11516,7 +10882,7 @@
           <a:noFill/>
         </p:spPr>
         <p:txBody>
-          <a:bodyPr wrap="square" lIns="0" rIns="0" tIns="0" bIns="0">
+          <a:bodyPr wrap="square" lIns="0" tIns="0" rIns="0" bIns="0">
             <a:spAutoFit/>
           </a:bodyPr>
           <a:lstStyle/>
@@ -11530,7 +10896,7 @@
               </a:defRPr>
             </a:pPr>
             <a:r>
-              <a:t>Financial Reports &amp; Audit Trail</a:t>
+              <a:t>System Operational Health &amp; Reports</a:t>
             </a:r>
           </a:p>
           <a:p>
@@ -11546,7 +10912,7 @@
               </a:defRPr>
             </a:pPr>
             <a:r>
-              <a:t>• Comprehensive order filters by date, department, status, vendor, and coordinator.</a:t>
+              <a:t>• Real-time database latency, WebSocket event gateway, and health analytics.</a:t>
             </a:r>
           </a:p>
           <a:p>
@@ -11562,7 +10928,7 @@
               </a:defRPr>
             </a:pPr>
             <a:r>
-              <a:t>• System health diagnostics, WebSocket monitor, and permanent security logs.</a:t>
+              <a:t>• Comprehensive order filters by date, department, status, vendor, and coordinator.</a:t>
             </a:r>
           </a:p>
         </p:txBody>
@@ -11575,8 +10941,8 @@
         </p:nvSpPr>
         <p:spPr>
           <a:xfrm>
-            <a:off x="6217920" y="1463040"/>
-            <a:ext cx="5242255" cy="4480560"/>
+            <a:off x="5815584" y="1426464"/>
+            <a:ext cx="5681167" cy="4553712"/>
           </a:xfrm>
           <a:prstGeom prst="roundRect">
             <a:avLst/>
@@ -11609,19 +10975,44 @@
           <a:lstStyle/>
           <a:p>
             <a:pPr algn="ctr"/>
-          </a:p>
-        </p:txBody>
-      </p:sp>
-      <p:sp>
-        <p:nvSpPr>
-          <p:cNvPr id="14" name="TextBox 13"/>
+            <a:endParaRPr/>
+          </a:p>
+        </p:txBody>
+      </p:sp>
+      <p:pic>
+        <p:nvPicPr>
+          <p:cNvPr id="14" name="Picture 13" descr="media_1787155691870.png"/>
+          <p:cNvPicPr>
+            <a:picLocks noChangeAspect="1"/>
+          </p:cNvPicPr>
+          <p:nvPr/>
+        </p:nvPicPr>
+        <p:blipFill>
+          <a:blip r:embed="rId2"/>
+          <a:stretch>
+            <a:fillRect/>
+          </a:stretch>
+        </p:blipFill>
+        <p:spPr>
+          <a:xfrm>
+            <a:off x="5783490" y="1408176"/>
+            <a:ext cx="5745354" cy="4590288"/>
+          </a:xfrm>
+          <a:prstGeom prst="rect">
+            <a:avLst/>
+          </a:prstGeom>
+        </p:spPr>
+      </p:pic>
+      <p:sp>
+        <p:nvSpPr>
+          <p:cNvPr id="15" name="TextBox 14"/>
           <p:cNvSpPr txBox="1"/>
           <p:nvPr/>
         </p:nvSpPr>
         <p:spPr>
           <a:xfrm>
-            <a:off x="6400800" y="3154680"/>
-            <a:ext cx="4876495" cy="1097280"/>
+            <a:off x="5852160" y="6016752"/>
+            <a:ext cx="5608015" cy="274320"/>
           </a:xfrm>
           <a:prstGeom prst="rect">
             <a:avLst/>
@@ -11629,13 +11020,13 @@
           <a:noFill/>
         </p:spPr>
         <p:txBody>
-          <a:bodyPr wrap="square" lIns="0" rIns="0" tIns="0" bIns="0">
+          <a:bodyPr wrap="none" lIns="0" tIns="0" rIns="0" bIns="0">
             <a:spAutoFit/>
           </a:bodyPr>
           <a:lstStyle/>
           <a:p>
             <a:pPr algn="ctr">
-              <a:defRPr sz="1200" b="1">
+              <a:defRPr sz="950" b="1">
                 <a:solidFill>
                   <a:srgbClr val="60A5FA"/>
                 </a:solidFill>
@@ -11643,33 +11034,7 @@
               </a:defRPr>
             </a:pPr>
             <a:r>
-              <a:t>📸 Admin Console Screenshot</a:t>
-            </a:r>
-          </a:p>
-          <a:p>
-            <a:pPr algn="ctr">
-              <a:defRPr sz="950">
-                <a:solidFill>
-                  <a:srgbClr val="94A3B8"/>
-                </a:solidFill>
-                <a:latin typeface="Arial"/>
-              </a:defRPr>
-            </a:pPr>
-            <a:r>
-              <a:t>Insert Admin User Management &amp; Reports Page Screenshot</a:t>
-            </a:r>
-          </a:p>
-          <a:p>
-            <a:pPr algn="ctr">
-              <a:defRPr sz="850" i="1">
-                <a:solidFill>
-                  <a:srgbClr val="94A3B8"/>
-                </a:solidFill>
-                <a:latin typeface="Arial"/>
-              </a:defRPr>
-            </a:pPr>
-            <a:r>
-              <a:t>(Right Click → Change Picture / Paste Screenshot)</a:t>
+              <a:t>📸 System Administrator Control &amp; Operational Health Console</a:t>
             </a:r>
           </a:p>
         </p:txBody>

</xml_diff>